<commit_message>
Polish public project presentation
</commit_message>
<xml_diff>
--- a/presentations/regional_route_marketing_science_case_study.pptx
+++ b/presentations/regional_route_marketing_science_case_study.pptx
@@ -2,20 +2,20 @@
 <file path=ppt/presentation.xml><?xml version="1.0" encoding="utf-8"?>
 <p:presentation xmlns:p="http://schemas.openxmlformats.org/presentationml/2006/main">
   <p:sldMasterIdLst>
-    <p:sldMasterId xmlns:r="http://schemas.openxmlformats.org/officeDocument/2006/relationships" id="2147483648" r:id="R0d9ef98554c44b9c"/>
+    <p:sldMasterId xmlns:r="http://schemas.openxmlformats.org/officeDocument/2006/relationships" id="2147483648" r:id="Re622aeff24c14193"/>
   </p:sldMasterIdLst>
   <p:notesMasterIdLst>
-    <p:notesMasterId xmlns:r="http://schemas.openxmlformats.org/officeDocument/2006/relationships" r:id="R5cc67b25002f4d4a"/>
+    <p:notesMasterId xmlns:r="http://schemas.openxmlformats.org/officeDocument/2006/relationships" r:id="R96a2f540f9714d50"/>
   </p:notesMasterIdLst>
   <p:sldIdLst>
-    <p:sldId xmlns:r="http://schemas.openxmlformats.org/officeDocument/2006/relationships" id="256" r:id="R875d257839914583"/>
-    <p:sldId xmlns:r="http://schemas.openxmlformats.org/officeDocument/2006/relationships" id="257" r:id="R3ed81040970b4d6c"/>
-    <p:sldId xmlns:r="http://schemas.openxmlformats.org/officeDocument/2006/relationships" id="258" r:id="Rd321d89262aa4222"/>
-    <p:sldId xmlns:r="http://schemas.openxmlformats.org/officeDocument/2006/relationships" id="259" r:id="Rae091dcdd254444f"/>
-    <p:sldId xmlns:r="http://schemas.openxmlformats.org/officeDocument/2006/relationships" id="260" r:id="Rceb11ddcb7ae405c"/>
-    <p:sldId xmlns:r="http://schemas.openxmlformats.org/officeDocument/2006/relationships" id="261" r:id="R2e4fb1026b8d41d1"/>
-    <p:sldId xmlns:r="http://schemas.openxmlformats.org/officeDocument/2006/relationships" id="262" r:id="Ra06b2dcf24284958"/>
-    <p:sldId xmlns:r="http://schemas.openxmlformats.org/officeDocument/2006/relationships" id="263" r:id="R851104069c9d4e38"/>
+    <p:sldId xmlns:r="http://schemas.openxmlformats.org/officeDocument/2006/relationships" id="256" r:id="Rcd42000924e14482"/>
+    <p:sldId xmlns:r="http://schemas.openxmlformats.org/officeDocument/2006/relationships" id="257" r:id="R400c128e90474a23"/>
+    <p:sldId xmlns:r="http://schemas.openxmlformats.org/officeDocument/2006/relationships" id="258" r:id="R012c95370b184045"/>
+    <p:sldId xmlns:r="http://schemas.openxmlformats.org/officeDocument/2006/relationships" id="259" r:id="R3596d974f27a432c"/>
+    <p:sldId xmlns:r="http://schemas.openxmlformats.org/officeDocument/2006/relationships" id="260" r:id="R5ede1c00d7df4590"/>
+    <p:sldId xmlns:r="http://schemas.openxmlformats.org/officeDocument/2006/relationships" id="261" r:id="Rf4237c56b1a94e0a"/>
+    <p:sldId xmlns:r="http://schemas.openxmlformats.org/officeDocument/2006/relationships" id="262" r:id="R082c08c0acca4dd2"/>
+    <p:sldId xmlns:r="http://schemas.openxmlformats.org/officeDocument/2006/relationships" id="263" r:id="Rb056fb9fefb94ca4"/>
   </p:sldIdLst>
   <p:sldSz cx="12192000" cy="6858000"/>
   <p:notesSz cx="6858000" cy="9144000"/>
@@ -534,7 +534,7 @@
           <a:lstStyle xmlns:a="http://schemas.openxmlformats.org/drawingml/2006/main"/>
           <a:p xmlns:a="http://schemas.openxmlformats.org/drawingml/2006/main">
             <a:r>
-              <a:t>This slide frames the problem at L4 DS level: ambiguous business decision, incomplete data, and a need to connect analysis to action.</a:t>
+              <a:t>This slide frames the problem as an ambiguous business decision under incomplete data, with a need to connect analysis to action.</a:t>
             </a:r>
           </a:p>
           <a:p xmlns:a="http://schemas.openxmlformats.org/drawingml/2006/main">
@@ -894,7 +894,7 @@
           <a:lstStyle xmlns:a="http://schemas.openxmlformats.org/drawingml/2006/main"/>
           <a:p xmlns:a="http://schemas.openxmlformats.org/drawingml/2006/main">
             <a:r>
-              <a:t>This is the key recommendation slide for an interview walkthrough.</a:t>
+              <a:t>This is the key recommendation slide for a project walkthrough.</a:t>
             </a:r>
           </a:p>
           <a:p xmlns:a="http://schemas.openxmlformats.org/drawingml/2006/main">
@@ -1182,7 +1182,7 @@
   </p:cSld>
   <p:clrMap bg1="lt1" tx1="dk1" bg2="lt2" tx2="dk2" accent1="accent1" accent2="accent2" accent3="accent3" accent4="accent4" accent5="accent5" accent6="accent6" hlink="hlink" folHlink="folHlink"/>
   <p:sldLayoutIdLst>
-    <p:sldLayoutId xmlns:r="http://schemas.openxmlformats.org/officeDocument/2006/relationships" id="2147483649" r:id="Rf1f43e70ca0946ab"/>
+    <p:sldLayoutId xmlns:r="http://schemas.openxmlformats.org/officeDocument/2006/relationships" id="2147483649" r:id="R78b25ded9d394e26"/>
   </p:sldLayoutIdLst>
   <p:txStyles>
     <p:titleStyle>
@@ -2232,7 +2232,7 @@
           <p:cNvPr id="6" name="">
             <a:extLst xmlns:a="http://schemas.openxmlformats.org/drawingml/2006/main">
               <a:ext uri="{FF2B5EF4-FFF2-40B4-BE49-F238E27FC236}">
-                <a16:creationId xmlns:a16="http://schemas.microsoft.com/office/drawing/2014/main" id="{42C7ECC8-9ED0-4C46-90ED-36B6671152E8}"/>
+                <a16:creationId xmlns:a16="http://schemas.microsoft.com/office/drawing/2014/main" id="{FF61CAA5-60F2-4FB5-9BA8-363B64568665}"/>
               </a:ext>
             </a:extLst>
           </p:cNvPr>
@@ -2282,7 +2282,7 @@
           <p:cNvPr id="2" name="">
             <a:extLst xmlns:a="http://schemas.openxmlformats.org/drawingml/2006/main">
               <a:ext uri="{FF2B5EF4-FFF2-40B4-BE49-F238E27FC236}">
-                <a16:creationId xmlns:a16="http://schemas.microsoft.com/office/drawing/2014/main" id="{12036A46-2045-4A37-8216-BED653B7F0E8}"/>
+                <a16:creationId xmlns:a16="http://schemas.microsoft.com/office/drawing/2014/main" id="{23F14BB0-5ABF-4B2C-89AB-74540CCBF4EB}"/>
               </a:ext>
             </a:extLst>
           </p:cNvPr>
@@ -2332,7 +2332,7 @@
           <p:cNvPr id="3" name="">
             <a:extLst xmlns:a="http://schemas.openxmlformats.org/drawingml/2006/main">
               <a:ext uri="{FF2B5EF4-FFF2-40B4-BE49-F238E27FC236}">
-                <a16:creationId xmlns:a16="http://schemas.microsoft.com/office/drawing/2014/main" id="{E50A5CD6-634A-4345-BC90-44DF94567EB5}"/>
+                <a16:creationId xmlns:a16="http://schemas.microsoft.com/office/drawing/2014/main" id="{27EBEABC-4E76-46FF-B80B-D56156AC1558}"/>
               </a:ext>
             </a:extLst>
           </p:cNvPr>
@@ -2382,7 +2382,7 @@
           <p:cNvPr id="4" name="">
             <a:extLst xmlns:a="http://schemas.openxmlformats.org/drawingml/2006/main">
               <a:ext uri="{FF2B5EF4-FFF2-40B4-BE49-F238E27FC236}">
-                <a16:creationId xmlns:a16="http://schemas.microsoft.com/office/drawing/2014/main" id="{7AE7188A-BCC4-4664-887D-8E983F195834}"/>
+                <a16:creationId xmlns:a16="http://schemas.microsoft.com/office/drawing/2014/main" id="{6B985C6E-CA19-4EB5-8249-017F01EF99D8}"/>
               </a:ext>
             </a:extLst>
           </p:cNvPr>
@@ -2413,7 +2413,7 @@
           <p:cNvPr id="5" name="">
             <a:extLst xmlns:a="http://schemas.openxmlformats.org/drawingml/2006/main">
               <a:ext uri="{FF2B5EF4-FFF2-40B4-BE49-F238E27FC236}">
-                <a16:creationId xmlns:a16="http://schemas.microsoft.com/office/drawing/2014/main" id="{2BD7FEE1-2BED-4BEE-A0A4-4B5AF06A151E}"/>
+                <a16:creationId xmlns:a16="http://schemas.microsoft.com/office/drawing/2014/main" id="{BF7819CA-F212-4B1A-A344-4440CD8806DC}"/>
               </a:ext>
             </a:extLst>
           </p:cNvPr>
@@ -2461,7 +2461,7 @@
     </p:spTree>
     <p:extLst>
       <p:ext uri="{BB962C8B-B14F-4D97-AF65-F5344CB8AC3E}">
-        <p14:creationId xmlns:p14="http://schemas.microsoft.com/office/powerpoint/2010/main" val="378528794"/>
+        <p14:creationId xmlns:p14="http://schemas.microsoft.com/office/powerpoint/2010/main" val="73904011"/>
       </p:ext>
     </p:extLst>
   </p:cSld>
@@ -2492,7 +2492,7 @@
           <p:cNvPr id="17" name="slide-2-title">
             <a:extLst xmlns:a="http://schemas.openxmlformats.org/drawingml/2006/main">
               <a:ext uri="{FF2B5EF4-FFF2-40B4-BE49-F238E27FC236}">
-                <a16:creationId xmlns:a16="http://schemas.microsoft.com/office/drawing/2014/main" id="{09E3715A-0AF1-4275-9146-573669A7EB69}"/>
+                <a16:creationId xmlns:a16="http://schemas.microsoft.com/office/drawing/2014/main" id="{CCF7C27F-F467-4EED-8E08-3CBDF3D1AB2D}"/>
               </a:ext>
             </a:extLst>
           </p:cNvPr>
@@ -2542,7 +2542,7 @@
           <p:cNvPr id="2" name="slide-2-subtitle">
             <a:extLst xmlns:a="http://schemas.openxmlformats.org/drawingml/2006/main">
               <a:ext uri="{FF2B5EF4-FFF2-40B4-BE49-F238E27FC236}">
-                <a16:creationId xmlns:a16="http://schemas.microsoft.com/office/drawing/2014/main" id="{4F51B9DA-5EF3-4D95-9304-3155C94CAFCB}"/>
+                <a16:creationId xmlns:a16="http://schemas.microsoft.com/office/drawing/2014/main" id="{62A230CC-02C0-408D-8E97-ADDA49889DF9}"/>
               </a:ext>
             </a:extLst>
           </p:cNvPr>
@@ -2592,7 +2592,7 @@
           <p:cNvPr id="3" name="slide-2-footer">
             <a:extLst xmlns:a="http://schemas.openxmlformats.org/drawingml/2006/main">
               <a:ext uri="{FF2B5EF4-FFF2-40B4-BE49-F238E27FC236}">
-                <a16:creationId xmlns:a16="http://schemas.microsoft.com/office/drawing/2014/main" id="{85CB9386-0A2F-4A55-B86F-CB6A36589E61}"/>
+                <a16:creationId xmlns:a16="http://schemas.microsoft.com/office/drawing/2014/main" id="{0E9AF743-58BE-463E-B97B-3DE06D92E745}"/>
               </a:ext>
             </a:extLst>
           </p:cNvPr>
@@ -2642,7 +2642,7 @@
           <p:cNvPr id="4" name="">
             <a:extLst xmlns:a="http://schemas.openxmlformats.org/drawingml/2006/main">
               <a:ext uri="{FF2B5EF4-FFF2-40B4-BE49-F238E27FC236}">
-                <a16:creationId xmlns:a16="http://schemas.microsoft.com/office/drawing/2014/main" id="{A0320759-7704-4C05-8E6B-F87EF83C551F}"/>
+                <a16:creationId xmlns:a16="http://schemas.microsoft.com/office/drawing/2014/main" id="{F3269C81-EEFC-4A53-A733-CB728E9459EF}"/>
               </a:ext>
             </a:extLst>
           </p:cNvPr>
@@ -2673,7 +2673,7 @@
           <p:cNvPr id="5" name="">
             <a:extLst xmlns:a="http://schemas.openxmlformats.org/drawingml/2006/main">
               <a:ext uri="{FF2B5EF4-FFF2-40B4-BE49-F238E27FC236}">
-                <a16:creationId xmlns:a16="http://schemas.microsoft.com/office/drawing/2014/main" id="{9D74F713-C141-4BC7-B2DA-F2247F5490D7}"/>
+                <a16:creationId xmlns:a16="http://schemas.microsoft.com/office/drawing/2014/main" id="{B18595A3-E85A-4304-903B-FC02F3B816B0}"/>
               </a:ext>
             </a:extLst>
           </p:cNvPr>
@@ -2723,7 +2723,7 @@
           <p:cNvPr id="6" name="">
             <a:extLst xmlns:a="http://schemas.openxmlformats.org/drawingml/2006/main">
               <a:ext uri="{FF2B5EF4-FFF2-40B4-BE49-F238E27FC236}">
-                <a16:creationId xmlns:a16="http://schemas.microsoft.com/office/drawing/2014/main" id="{E71187B7-E484-4478-B818-381A5851542A}"/>
+                <a16:creationId xmlns:a16="http://schemas.microsoft.com/office/drawing/2014/main" id="{3BA726B0-F800-4603-968B-4278D20FC0EE}"/>
               </a:ext>
             </a:extLst>
           </p:cNvPr>
@@ -2773,7 +2773,7 @@
           <p:cNvPr id="7" name="">
             <a:extLst xmlns:a="http://schemas.openxmlformats.org/drawingml/2006/main">
               <a:ext uri="{FF2B5EF4-FFF2-40B4-BE49-F238E27FC236}">
-                <a16:creationId xmlns:a16="http://schemas.microsoft.com/office/drawing/2014/main" id="{E84D0DEB-53CD-4156-8C19-2FC6960C766B}"/>
+                <a16:creationId xmlns:a16="http://schemas.microsoft.com/office/drawing/2014/main" id="{C8A53052-AEE3-4108-843A-CC66A72799BE}"/>
               </a:ext>
             </a:extLst>
           </p:cNvPr>
@@ -2806,7 +2806,7 @@
           <p:cNvPr id="8" name="">
             <a:extLst xmlns:a="http://schemas.openxmlformats.org/drawingml/2006/main">
               <a:ext uri="{FF2B5EF4-FFF2-40B4-BE49-F238E27FC236}">
-                <a16:creationId xmlns:a16="http://schemas.microsoft.com/office/drawing/2014/main" id="{5362A1FB-8ED0-4F90-BB37-5A77A79FFD4E}"/>
+                <a16:creationId xmlns:a16="http://schemas.microsoft.com/office/drawing/2014/main" id="{13AF882F-8DB9-46BB-ABB3-A468BD6A37DE}"/>
               </a:ext>
             </a:extLst>
           </p:cNvPr>
@@ -2856,7 +2856,7 @@
           <p:cNvPr id="9" name="">
             <a:extLst xmlns:a="http://schemas.openxmlformats.org/drawingml/2006/main">
               <a:ext uri="{FF2B5EF4-FFF2-40B4-BE49-F238E27FC236}">
-                <a16:creationId xmlns:a16="http://schemas.microsoft.com/office/drawing/2014/main" id="{0D6DAE52-F0AF-4104-AB27-83F32C600B44}"/>
+                <a16:creationId xmlns:a16="http://schemas.microsoft.com/office/drawing/2014/main" id="{19E3B917-D44D-4E11-A794-8E57F44696B6}"/>
               </a:ext>
             </a:extLst>
           </p:cNvPr>
@@ -2887,7 +2887,7 @@
           <p:cNvPr id="10" name="">
             <a:extLst xmlns:a="http://schemas.openxmlformats.org/drawingml/2006/main">
               <a:ext uri="{FF2B5EF4-FFF2-40B4-BE49-F238E27FC236}">
-                <a16:creationId xmlns:a16="http://schemas.microsoft.com/office/drawing/2014/main" id="{BA6BFE9E-BA5E-4E09-8791-AD3385CE786B}"/>
+                <a16:creationId xmlns:a16="http://schemas.microsoft.com/office/drawing/2014/main" id="{38D18DAE-EA42-4E7A-96C4-7C2A43E324A3}"/>
               </a:ext>
             </a:extLst>
           </p:cNvPr>
@@ -2937,7 +2937,7 @@
           <p:cNvPr id="11" name="">
             <a:extLst xmlns:a="http://schemas.openxmlformats.org/drawingml/2006/main">
               <a:ext uri="{FF2B5EF4-FFF2-40B4-BE49-F238E27FC236}">
-                <a16:creationId xmlns:a16="http://schemas.microsoft.com/office/drawing/2014/main" id="{E616CAB8-F2E4-4AB9-A37A-29C0E354D9F5}"/>
+                <a16:creationId xmlns:a16="http://schemas.microsoft.com/office/drawing/2014/main" id="{DCD84E1F-2F6E-43EA-9959-EE786B48D262}"/>
               </a:ext>
             </a:extLst>
           </p:cNvPr>
@@ -2968,7 +2968,7 @@
           <p:cNvPr id="12" name="">
             <a:extLst xmlns:a="http://schemas.openxmlformats.org/drawingml/2006/main">
               <a:ext uri="{FF2B5EF4-FFF2-40B4-BE49-F238E27FC236}">
-                <a16:creationId xmlns:a16="http://schemas.microsoft.com/office/drawing/2014/main" id="{5EB09AAE-36A7-48D9-A068-DF959774DA13}"/>
+                <a16:creationId xmlns:a16="http://schemas.microsoft.com/office/drawing/2014/main" id="{6255DAA4-FCC5-4FE5-BF58-453191585097}"/>
               </a:ext>
             </a:extLst>
           </p:cNvPr>
@@ -3018,7 +3018,7 @@
           <p:cNvPr id="13" name="">
             <a:extLst xmlns:a="http://schemas.openxmlformats.org/drawingml/2006/main">
               <a:ext uri="{FF2B5EF4-FFF2-40B4-BE49-F238E27FC236}">
-                <a16:creationId xmlns:a16="http://schemas.microsoft.com/office/drawing/2014/main" id="{23F08C79-B6F0-41B1-9A97-A64B1FECAB38}"/>
+                <a16:creationId xmlns:a16="http://schemas.microsoft.com/office/drawing/2014/main" id="{80096146-D263-4C13-BB35-C8ED3C7895A5}"/>
               </a:ext>
             </a:extLst>
           </p:cNvPr>
@@ -3049,7 +3049,7 @@
           <p:cNvPr id="14" name="">
             <a:extLst xmlns:a="http://schemas.openxmlformats.org/drawingml/2006/main">
               <a:ext uri="{FF2B5EF4-FFF2-40B4-BE49-F238E27FC236}">
-                <a16:creationId xmlns:a16="http://schemas.microsoft.com/office/drawing/2014/main" id="{F6FDA5DC-732A-4626-83BC-6982BE4D1A94}"/>
+                <a16:creationId xmlns:a16="http://schemas.microsoft.com/office/drawing/2014/main" id="{CCA31002-9F3A-4B59-9781-F9FA9F878A6B}"/>
               </a:ext>
             </a:extLst>
           </p:cNvPr>
@@ -3099,7 +3099,7 @@
           <p:cNvPr id="15" name="">
             <a:extLst xmlns:a="http://schemas.openxmlformats.org/drawingml/2006/main">
               <a:ext uri="{FF2B5EF4-FFF2-40B4-BE49-F238E27FC236}">
-                <a16:creationId xmlns:a16="http://schemas.microsoft.com/office/drawing/2014/main" id="{F2E0A9F9-6D1D-46DC-BBC5-826DF5BBE687}"/>
+                <a16:creationId xmlns:a16="http://schemas.microsoft.com/office/drawing/2014/main" id="{81D58FC5-58F0-4631-8C53-9A73D78A4058}"/>
               </a:ext>
             </a:extLst>
           </p:cNvPr>
@@ -3130,7 +3130,7 @@
           <p:cNvPr id="16" name="">
             <a:extLst xmlns:a="http://schemas.openxmlformats.org/drawingml/2006/main">
               <a:ext uri="{FF2B5EF4-FFF2-40B4-BE49-F238E27FC236}">
-                <a16:creationId xmlns:a16="http://schemas.microsoft.com/office/drawing/2014/main" id="{04204F18-6336-4108-A446-40666ABC5BA1}"/>
+                <a16:creationId xmlns:a16="http://schemas.microsoft.com/office/drawing/2014/main" id="{FB0675F8-ACEB-47D4-AE9E-988FD2217454}"/>
               </a:ext>
             </a:extLst>
           </p:cNvPr>
@@ -3178,7 +3178,7 @@
     </p:spTree>
     <p:extLst>
       <p:ext uri="{BB962C8B-B14F-4D97-AF65-F5344CB8AC3E}">
-        <p14:creationId xmlns:p14="http://schemas.microsoft.com/office/powerpoint/2010/main" val="724816605"/>
+        <p14:creationId xmlns:p14="http://schemas.microsoft.com/office/powerpoint/2010/main" val="998859392"/>
       </p:ext>
     </p:extLst>
   </p:cSld>
@@ -3209,7 +3209,7 @@
           <p:cNvPr id="19" name="slide-3-title">
             <a:extLst xmlns:a="http://schemas.openxmlformats.org/drawingml/2006/main">
               <a:ext uri="{FF2B5EF4-FFF2-40B4-BE49-F238E27FC236}">
-                <a16:creationId xmlns:a16="http://schemas.microsoft.com/office/drawing/2014/main" id="{3C8CBD00-99EF-4162-8105-57536FCAA140}"/>
+                <a16:creationId xmlns:a16="http://schemas.microsoft.com/office/drawing/2014/main" id="{53BF663A-F99E-4708-8061-126A18DC2FBD}"/>
               </a:ext>
             </a:extLst>
           </p:cNvPr>
@@ -3259,7 +3259,7 @@
           <p:cNvPr id="2" name="slide-3-subtitle">
             <a:extLst xmlns:a="http://schemas.openxmlformats.org/drawingml/2006/main">
               <a:ext uri="{FF2B5EF4-FFF2-40B4-BE49-F238E27FC236}">
-                <a16:creationId xmlns:a16="http://schemas.microsoft.com/office/drawing/2014/main" id="{A7D80BB5-8D2E-40EE-99B6-C827EC6FD1C0}"/>
+                <a16:creationId xmlns:a16="http://schemas.microsoft.com/office/drawing/2014/main" id="{ADA823D2-1942-418B-9369-79D139CC82A9}"/>
               </a:ext>
             </a:extLst>
           </p:cNvPr>
@@ -3309,7 +3309,7 @@
           <p:cNvPr id="3" name="slide-3-footer">
             <a:extLst xmlns:a="http://schemas.openxmlformats.org/drawingml/2006/main">
               <a:ext uri="{FF2B5EF4-FFF2-40B4-BE49-F238E27FC236}">
-                <a16:creationId xmlns:a16="http://schemas.microsoft.com/office/drawing/2014/main" id="{EBDB2F18-5B68-443D-B91C-D42D2D035A8D}"/>
+                <a16:creationId xmlns:a16="http://schemas.microsoft.com/office/drawing/2014/main" id="{C94FA373-A032-46D8-BD1F-FFBD8A24862A}"/>
               </a:ext>
             </a:extLst>
           </p:cNvPr>
@@ -3359,7 +3359,7 @@
           <p:cNvPr id="4" name="">
             <a:extLst xmlns:a="http://schemas.openxmlformats.org/drawingml/2006/main">
               <a:ext uri="{FF2B5EF4-FFF2-40B4-BE49-F238E27FC236}">
-                <a16:creationId xmlns:a16="http://schemas.microsoft.com/office/drawing/2014/main" id="{A1305A33-8D56-4DC4-8380-3AACF8600703}"/>
+                <a16:creationId xmlns:a16="http://schemas.microsoft.com/office/drawing/2014/main" id="{9F11EC93-3032-48F1-8FAA-611911077DD7}"/>
               </a:ext>
             </a:extLst>
           </p:cNvPr>
@@ -3390,7 +3390,7 @@
           <p:cNvPr id="5" name="">
             <a:extLst xmlns:a="http://schemas.openxmlformats.org/drawingml/2006/main">
               <a:ext uri="{FF2B5EF4-FFF2-40B4-BE49-F238E27FC236}">
-                <a16:creationId xmlns:a16="http://schemas.microsoft.com/office/drawing/2014/main" id="{2D775E70-056B-4DA3-967F-39137A48CE1A}"/>
+                <a16:creationId xmlns:a16="http://schemas.microsoft.com/office/drawing/2014/main" id="{F4B11204-FD5F-4187-8FC8-FF665A17B78C}"/>
               </a:ext>
             </a:extLst>
           </p:cNvPr>
@@ -3440,7 +3440,7 @@
           <p:cNvPr id="6" name="">
             <a:extLst xmlns:a="http://schemas.openxmlformats.org/drawingml/2006/main">
               <a:ext uri="{FF2B5EF4-FFF2-40B4-BE49-F238E27FC236}">
-                <a16:creationId xmlns:a16="http://schemas.microsoft.com/office/drawing/2014/main" id="{46A90CA2-227C-462E-926A-CEFD98BFB041}"/>
+                <a16:creationId xmlns:a16="http://schemas.microsoft.com/office/drawing/2014/main" id="{8BD2F9F4-E78F-414B-AF67-092862B96470}"/>
               </a:ext>
             </a:extLst>
           </p:cNvPr>
@@ -3490,7 +3490,7 @@
           <p:cNvPr id="7" name="">
             <a:extLst xmlns:a="http://schemas.openxmlformats.org/drawingml/2006/main">
               <a:ext uri="{FF2B5EF4-FFF2-40B4-BE49-F238E27FC236}">
-                <a16:creationId xmlns:a16="http://schemas.microsoft.com/office/drawing/2014/main" id="{3584836B-2BE7-48DF-B8B4-284650D0B9E8}"/>
+                <a16:creationId xmlns:a16="http://schemas.microsoft.com/office/drawing/2014/main" id="{1034FF68-83DF-4C6D-8BE7-942A90EF2E20}"/>
               </a:ext>
             </a:extLst>
           </p:cNvPr>
@@ -3540,7 +3540,7 @@
           <p:cNvPr id="8" name="">
             <a:extLst xmlns:a="http://schemas.openxmlformats.org/drawingml/2006/main">
               <a:ext uri="{FF2B5EF4-FFF2-40B4-BE49-F238E27FC236}">
-                <a16:creationId xmlns:a16="http://schemas.microsoft.com/office/drawing/2014/main" id="{BADDD828-CBD2-4FCA-AF25-37E9C5BB534D}"/>
+                <a16:creationId xmlns:a16="http://schemas.microsoft.com/office/drawing/2014/main" id="{7BE5EFE8-0580-43EA-971B-1565F4D00BF9}"/>
               </a:ext>
             </a:extLst>
           </p:cNvPr>
@@ -3571,7 +3571,7 @@
           <p:cNvPr id="9" name="">
             <a:extLst xmlns:a="http://schemas.openxmlformats.org/drawingml/2006/main">
               <a:ext uri="{FF2B5EF4-FFF2-40B4-BE49-F238E27FC236}">
-                <a16:creationId xmlns:a16="http://schemas.microsoft.com/office/drawing/2014/main" id="{D1BD8AA5-FCFD-4FD7-881D-6E5C795E19FA}"/>
+                <a16:creationId xmlns:a16="http://schemas.microsoft.com/office/drawing/2014/main" id="{C0D57981-3129-47BF-88A2-19A7BCF7399F}"/>
               </a:ext>
             </a:extLst>
           </p:cNvPr>
@@ -3602,7 +3602,7 @@
           <p:cNvPr id="10" name="">
             <a:extLst xmlns:a="http://schemas.openxmlformats.org/drawingml/2006/main">
               <a:ext uri="{FF2B5EF4-FFF2-40B4-BE49-F238E27FC236}">
-                <a16:creationId xmlns:a16="http://schemas.microsoft.com/office/drawing/2014/main" id="{01E2EAF5-43FE-42BB-AC89-150D8250C4F1}"/>
+                <a16:creationId xmlns:a16="http://schemas.microsoft.com/office/drawing/2014/main" id="{AB04D833-F4CD-440C-A399-6914AB325073}"/>
               </a:ext>
             </a:extLst>
           </p:cNvPr>
@@ -3652,7 +3652,7 @@
           <p:cNvPr id="11" name="">
             <a:extLst xmlns:a="http://schemas.openxmlformats.org/drawingml/2006/main">
               <a:ext uri="{FF2B5EF4-FFF2-40B4-BE49-F238E27FC236}">
-                <a16:creationId xmlns:a16="http://schemas.microsoft.com/office/drawing/2014/main" id="{FD58DB67-9DAB-4F87-877B-10EC97B72255}"/>
+                <a16:creationId xmlns:a16="http://schemas.microsoft.com/office/drawing/2014/main" id="{E426D564-83DF-4A54-9D31-14EBACB29D29}"/>
               </a:ext>
             </a:extLst>
           </p:cNvPr>
@@ -3702,7 +3702,7 @@
           <p:cNvPr id="12" name="">
             <a:extLst xmlns:a="http://schemas.openxmlformats.org/drawingml/2006/main">
               <a:ext uri="{FF2B5EF4-FFF2-40B4-BE49-F238E27FC236}">
-                <a16:creationId xmlns:a16="http://schemas.microsoft.com/office/drawing/2014/main" id="{B8B93F9B-B3AE-45CA-A270-6E97E31C93F0}"/>
+                <a16:creationId xmlns:a16="http://schemas.microsoft.com/office/drawing/2014/main" id="{9A9F83EB-2592-4991-AD67-7302A50DA72D}"/>
               </a:ext>
             </a:extLst>
           </p:cNvPr>
@@ -3752,7 +3752,7 @@
           <p:cNvPr id="13" name="">
             <a:extLst xmlns:a="http://schemas.openxmlformats.org/drawingml/2006/main">
               <a:ext uri="{FF2B5EF4-FFF2-40B4-BE49-F238E27FC236}">
-                <a16:creationId xmlns:a16="http://schemas.microsoft.com/office/drawing/2014/main" id="{10AE70A6-AB87-4A96-AF41-4D03D90036BF}"/>
+                <a16:creationId xmlns:a16="http://schemas.microsoft.com/office/drawing/2014/main" id="{7AAC6DE6-CD0E-4CC8-BA1D-0754C7B26DB9}"/>
               </a:ext>
             </a:extLst>
           </p:cNvPr>
@@ -3783,7 +3783,7 @@
           <p:cNvPr id="14" name="">
             <a:extLst xmlns:a="http://schemas.openxmlformats.org/drawingml/2006/main">
               <a:ext uri="{FF2B5EF4-FFF2-40B4-BE49-F238E27FC236}">
-                <a16:creationId xmlns:a16="http://schemas.microsoft.com/office/drawing/2014/main" id="{82CCF39E-9B28-4191-8021-9E00AF918B4C}"/>
+                <a16:creationId xmlns:a16="http://schemas.microsoft.com/office/drawing/2014/main" id="{85134724-1DAC-4420-8A4E-AC2633492092}"/>
               </a:ext>
             </a:extLst>
           </p:cNvPr>
@@ -3814,7 +3814,7 @@
           <p:cNvPr id="15" name="">
             <a:extLst xmlns:a="http://schemas.openxmlformats.org/drawingml/2006/main">
               <a:ext uri="{FF2B5EF4-FFF2-40B4-BE49-F238E27FC236}">
-                <a16:creationId xmlns:a16="http://schemas.microsoft.com/office/drawing/2014/main" id="{5A954BAC-BB76-427D-ACD1-2E28CB5C12CA}"/>
+                <a16:creationId xmlns:a16="http://schemas.microsoft.com/office/drawing/2014/main" id="{E5C28E93-AB8F-4B6C-9BFC-883EBFBE96F4}"/>
               </a:ext>
             </a:extLst>
           </p:cNvPr>
@@ -3864,7 +3864,7 @@
           <p:cNvPr id="16" name="">
             <a:extLst xmlns:a="http://schemas.openxmlformats.org/drawingml/2006/main">
               <a:ext uri="{FF2B5EF4-FFF2-40B4-BE49-F238E27FC236}">
-                <a16:creationId xmlns:a16="http://schemas.microsoft.com/office/drawing/2014/main" id="{3190EBEA-10B8-4F13-9F20-C74E864E871E}"/>
+                <a16:creationId xmlns:a16="http://schemas.microsoft.com/office/drawing/2014/main" id="{7A213663-2CD7-4D6B-99A2-6303062A45AD}"/>
               </a:ext>
             </a:extLst>
           </p:cNvPr>
@@ -3914,7 +3914,7 @@
           <p:cNvPr id="17" name="">
             <a:extLst xmlns:a="http://schemas.openxmlformats.org/drawingml/2006/main">
               <a:ext uri="{FF2B5EF4-FFF2-40B4-BE49-F238E27FC236}">
-                <a16:creationId xmlns:a16="http://schemas.microsoft.com/office/drawing/2014/main" id="{B1684C1A-75B9-4183-8D58-70D74CA515C6}"/>
+                <a16:creationId xmlns:a16="http://schemas.microsoft.com/office/drawing/2014/main" id="{AACE9C53-5837-4B0C-BF4A-F79B1AAC8959}"/>
               </a:ext>
             </a:extLst>
           </p:cNvPr>
@@ -3964,7 +3964,7 @@
           <p:cNvPr id="18" name="">
             <a:extLst xmlns:a="http://schemas.openxmlformats.org/drawingml/2006/main">
               <a:ext uri="{FF2B5EF4-FFF2-40B4-BE49-F238E27FC236}">
-                <a16:creationId xmlns:a16="http://schemas.microsoft.com/office/drawing/2014/main" id="{775E2A3B-C3BC-4EF1-9C4E-FD6A51B87979}"/>
+                <a16:creationId xmlns:a16="http://schemas.microsoft.com/office/drawing/2014/main" id="{12E06895-F363-4F5E-8A93-3A78DD6C5C91}"/>
               </a:ext>
             </a:extLst>
           </p:cNvPr>
@@ -4012,7 +4012,7 @@
     </p:spTree>
     <p:extLst>
       <p:ext uri="{BB962C8B-B14F-4D97-AF65-F5344CB8AC3E}">
-        <p14:creationId xmlns:p14="http://schemas.microsoft.com/office/powerpoint/2010/main" val="761564449"/>
+        <p14:creationId xmlns:p14="http://schemas.microsoft.com/office/powerpoint/2010/main" val="514505538"/>
       </p:ext>
     </p:extLst>
   </p:cSld>
@@ -4043,7 +4043,7 @@
           <p:cNvPr id="72" name="slide-4-title">
             <a:extLst xmlns:a="http://schemas.openxmlformats.org/drawingml/2006/main">
               <a:ext uri="{FF2B5EF4-FFF2-40B4-BE49-F238E27FC236}">
-                <a16:creationId xmlns:a16="http://schemas.microsoft.com/office/drawing/2014/main" id="{539D5F8E-3D28-4EFA-B99C-5F4418F4B7F7}"/>
+                <a16:creationId xmlns:a16="http://schemas.microsoft.com/office/drawing/2014/main" id="{013E39DC-B793-44C3-805E-FE4BF3DE726F}"/>
               </a:ext>
             </a:extLst>
           </p:cNvPr>
@@ -4093,7 +4093,7 @@
           <p:cNvPr id="2" name="slide-4-subtitle">
             <a:extLst xmlns:a="http://schemas.openxmlformats.org/drawingml/2006/main">
               <a:ext uri="{FF2B5EF4-FFF2-40B4-BE49-F238E27FC236}">
-                <a16:creationId xmlns:a16="http://schemas.microsoft.com/office/drawing/2014/main" id="{E2C9CE98-4C58-40A7-9F10-45B0CC51B517}"/>
+                <a16:creationId xmlns:a16="http://schemas.microsoft.com/office/drawing/2014/main" id="{B9773A3C-9E45-449B-A9F8-32D126A23C71}"/>
               </a:ext>
             </a:extLst>
           </p:cNvPr>
@@ -4143,7 +4143,7 @@
           <p:cNvPr id="3" name="slide-4-footer">
             <a:extLst xmlns:a="http://schemas.openxmlformats.org/drawingml/2006/main">
               <a:ext uri="{FF2B5EF4-FFF2-40B4-BE49-F238E27FC236}">
-                <a16:creationId xmlns:a16="http://schemas.microsoft.com/office/drawing/2014/main" id="{EB0AA2C0-BF72-4561-B3B5-5390A4773F49}"/>
+                <a16:creationId xmlns:a16="http://schemas.microsoft.com/office/drawing/2014/main" id="{2E557FF5-41D2-449A-8E2E-2A0704790D1C}"/>
               </a:ext>
             </a:extLst>
           </p:cNvPr>
@@ -4193,7 +4193,7 @@
           <p:cNvPr id="4" name="">
             <a:extLst xmlns:a="http://schemas.openxmlformats.org/drawingml/2006/main">
               <a:ext uri="{FF2B5EF4-FFF2-40B4-BE49-F238E27FC236}">
-                <a16:creationId xmlns:a16="http://schemas.microsoft.com/office/drawing/2014/main" id="{BD59157A-EDAD-4925-8574-7668BF7C4938}"/>
+                <a16:creationId xmlns:a16="http://schemas.microsoft.com/office/drawing/2014/main" id="{069A88B0-8A57-4147-BCD5-184EF93B8054}"/>
               </a:ext>
             </a:extLst>
           </p:cNvPr>
@@ -4226,7 +4226,7 @@
           <p:cNvPr id="5" name="">
             <a:extLst xmlns:a="http://schemas.openxmlformats.org/drawingml/2006/main">
               <a:ext uri="{FF2B5EF4-FFF2-40B4-BE49-F238E27FC236}">
-                <a16:creationId xmlns:a16="http://schemas.microsoft.com/office/drawing/2014/main" id="{CF0A7640-5A5B-43D2-B89D-FA07B57B752A}"/>
+                <a16:creationId xmlns:a16="http://schemas.microsoft.com/office/drawing/2014/main" id="{DC2720CE-6CA5-4B4D-82A0-99AF24E78FC0}"/>
               </a:ext>
             </a:extLst>
           </p:cNvPr>
@@ -4257,7 +4257,7 @@
           <p:cNvPr id="6" name="">
             <a:extLst xmlns:a="http://schemas.openxmlformats.org/drawingml/2006/main">
               <a:ext uri="{FF2B5EF4-FFF2-40B4-BE49-F238E27FC236}">
-                <a16:creationId xmlns:a16="http://schemas.microsoft.com/office/drawing/2014/main" id="{72014FDB-B589-4DB8-891B-43A94852B5B8}"/>
+                <a16:creationId xmlns:a16="http://schemas.microsoft.com/office/drawing/2014/main" id="{CA292ADB-2AAF-4558-A2A2-69520349C923}"/>
               </a:ext>
             </a:extLst>
           </p:cNvPr>
@@ -4288,7 +4288,7 @@
           <p:cNvPr id="7" name="">
             <a:extLst xmlns:a="http://schemas.openxmlformats.org/drawingml/2006/main">
               <a:ext uri="{FF2B5EF4-FFF2-40B4-BE49-F238E27FC236}">
-                <a16:creationId xmlns:a16="http://schemas.microsoft.com/office/drawing/2014/main" id="{95907986-69A0-4E0B-A796-A8D258D99C38}"/>
+                <a16:creationId xmlns:a16="http://schemas.microsoft.com/office/drawing/2014/main" id="{9AF42875-D38E-4865-9FC7-9620E1794902}"/>
               </a:ext>
             </a:extLst>
           </p:cNvPr>
@@ -4319,7 +4319,7 @@
           <p:cNvPr id="8" name="">
             <a:extLst xmlns:a="http://schemas.openxmlformats.org/drawingml/2006/main">
               <a:ext uri="{FF2B5EF4-FFF2-40B4-BE49-F238E27FC236}">
-                <a16:creationId xmlns:a16="http://schemas.microsoft.com/office/drawing/2014/main" id="{C3CAD3D2-CB7F-4774-BF03-4F5F86E49399}"/>
+                <a16:creationId xmlns:a16="http://schemas.microsoft.com/office/drawing/2014/main" id="{AD880B61-CF0C-42A6-9D65-2A233ABF45E8}"/>
               </a:ext>
             </a:extLst>
           </p:cNvPr>
@@ -4350,7 +4350,7 @@
           <p:cNvPr id="9" name="">
             <a:extLst xmlns:a="http://schemas.openxmlformats.org/drawingml/2006/main">
               <a:ext uri="{FF2B5EF4-FFF2-40B4-BE49-F238E27FC236}">
-                <a16:creationId xmlns:a16="http://schemas.microsoft.com/office/drawing/2014/main" id="{E5667B14-448E-46F6-AC7F-9B25722AC20D}"/>
+                <a16:creationId xmlns:a16="http://schemas.microsoft.com/office/drawing/2014/main" id="{4D34F0A2-2E40-4108-8D2D-CC67A2684778}"/>
               </a:ext>
             </a:extLst>
           </p:cNvPr>
@@ -4381,7 +4381,7 @@
           <p:cNvPr id="10" name="">
             <a:extLst xmlns:a="http://schemas.openxmlformats.org/drawingml/2006/main">
               <a:ext uri="{FF2B5EF4-FFF2-40B4-BE49-F238E27FC236}">
-                <a16:creationId xmlns:a16="http://schemas.microsoft.com/office/drawing/2014/main" id="{EF18DF35-D2AC-4334-903F-D4885D97ED65}"/>
+                <a16:creationId xmlns:a16="http://schemas.microsoft.com/office/drawing/2014/main" id="{758BF6C7-E67F-4573-94EA-7AAD385344A4}"/>
               </a:ext>
             </a:extLst>
           </p:cNvPr>
@@ -4412,7 +4412,7 @@
           <p:cNvPr id="11" name="">
             <a:extLst xmlns:a="http://schemas.openxmlformats.org/drawingml/2006/main">
               <a:ext uri="{FF2B5EF4-FFF2-40B4-BE49-F238E27FC236}">
-                <a16:creationId xmlns:a16="http://schemas.microsoft.com/office/drawing/2014/main" id="{6B5FAD9E-1329-40D7-9A4D-459C74165CEE}"/>
+                <a16:creationId xmlns:a16="http://schemas.microsoft.com/office/drawing/2014/main" id="{9238159A-3044-4606-B0A9-506CB991E1C2}"/>
               </a:ext>
             </a:extLst>
           </p:cNvPr>
@@ -4443,7 +4443,7 @@
           <p:cNvPr id="12" name="">
             <a:extLst xmlns:a="http://schemas.openxmlformats.org/drawingml/2006/main">
               <a:ext uri="{FF2B5EF4-FFF2-40B4-BE49-F238E27FC236}">
-                <a16:creationId xmlns:a16="http://schemas.microsoft.com/office/drawing/2014/main" id="{D708CC8D-888A-45B0-A8D8-9C59DC4908C8}"/>
+                <a16:creationId xmlns:a16="http://schemas.microsoft.com/office/drawing/2014/main" id="{0CABE47E-481E-4C0C-8C96-5B11FFFDA22D}"/>
               </a:ext>
             </a:extLst>
           </p:cNvPr>
@@ -4474,7 +4474,7 @@
           <p:cNvPr id="13" name="">
             <a:extLst xmlns:a="http://schemas.openxmlformats.org/drawingml/2006/main">
               <a:ext uri="{FF2B5EF4-FFF2-40B4-BE49-F238E27FC236}">
-                <a16:creationId xmlns:a16="http://schemas.microsoft.com/office/drawing/2014/main" id="{2868BFD4-F16A-47A5-AAE6-323EAF155BD3}"/>
+                <a16:creationId xmlns:a16="http://schemas.microsoft.com/office/drawing/2014/main" id="{6AEDFAF5-4EA8-45EC-9EC6-84473E2B2127}"/>
               </a:ext>
             </a:extLst>
           </p:cNvPr>
@@ -4505,7 +4505,7 @@
           <p:cNvPr id="14" name="">
             <a:extLst xmlns:a="http://schemas.openxmlformats.org/drawingml/2006/main">
               <a:ext uri="{FF2B5EF4-FFF2-40B4-BE49-F238E27FC236}">
-                <a16:creationId xmlns:a16="http://schemas.microsoft.com/office/drawing/2014/main" id="{6C257164-CC83-4BC8-A965-D8759BA93532}"/>
+                <a16:creationId xmlns:a16="http://schemas.microsoft.com/office/drawing/2014/main" id="{251D3264-40EB-4731-A242-C1EB020B0D04}"/>
               </a:ext>
             </a:extLst>
           </p:cNvPr>
@@ -4536,7 +4536,7 @@
           <p:cNvPr id="15" name="">
             <a:extLst xmlns:a="http://schemas.openxmlformats.org/drawingml/2006/main">
               <a:ext uri="{FF2B5EF4-FFF2-40B4-BE49-F238E27FC236}">
-                <a16:creationId xmlns:a16="http://schemas.microsoft.com/office/drawing/2014/main" id="{A2140E53-5BB3-4312-86B4-73AE53519D23}"/>
+                <a16:creationId xmlns:a16="http://schemas.microsoft.com/office/drawing/2014/main" id="{6E143DA4-165F-48A4-9C01-2CBEA5CC5961}"/>
               </a:ext>
             </a:extLst>
           </p:cNvPr>
@@ -4567,7 +4567,7 @@
           <p:cNvPr id="16" name="">
             <a:extLst xmlns:a="http://schemas.openxmlformats.org/drawingml/2006/main">
               <a:ext uri="{FF2B5EF4-FFF2-40B4-BE49-F238E27FC236}">
-                <a16:creationId xmlns:a16="http://schemas.microsoft.com/office/drawing/2014/main" id="{AB7BB973-286D-4422-B70E-028C4205CC1B}"/>
+                <a16:creationId xmlns:a16="http://schemas.microsoft.com/office/drawing/2014/main" id="{88482C98-6000-4DD6-B279-9F3DBBE8B5CE}"/>
               </a:ext>
             </a:extLst>
           </p:cNvPr>
@@ -4598,7 +4598,7 @@
           <p:cNvPr id="17" name="">
             <a:extLst xmlns:a="http://schemas.openxmlformats.org/drawingml/2006/main">
               <a:ext uri="{FF2B5EF4-FFF2-40B4-BE49-F238E27FC236}">
-                <a16:creationId xmlns:a16="http://schemas.microsoft.com/office/drawing/2014/main" id="{99713DF1-331A-426D-9175-57A4F45E6A36}"/>
+                <a16:creationId xmlns:a16="http://schemas.microsoft.com/office/drawing/2014/main" id="{75FFE217-6582-4E52-AD1E-F7A15C1543C5}"/>
               </a:ext>
             </a:extLst>
           </p:cNvPr>
@@ -4629,7 +4629,7 @@
           <p:cNvPr id="18" name="">
             <a:extLst xmlns:a="http://schemas.openxmlformats.org/drawingml/2006/main">
               <a:ext uri="{FF2B5EF4-FFF2-40B4-BE49-F238E27FC236}">
-                <a16:creationId xmlns:a16="http://schemas.microsoft.com/office/drawing/2014/main" id="{BE7848F2-3B15-4CAE-985D-D5104FEF3D11}"/>
+                <a16:creationId xmlns:a16="http://schemas.microsoft.com/office/drawing/2014/main" id="{EC0AF358-1751-4243-80FB-E86DCD1713C2}"/>
               </a:ext>
             </a:extLst>
           </p:cNvPr>
@@ -4679,7 +4679,7 @@
           <p:cNvPr id="19" name="">
             <a:extLst xmlns:a="http://schemas.openxmlformats.org/drawingml/2006/main">
               <a:ext uri="{FF2B5EF4-FFF2-40B4-BE49-F238E27FC236}">
-                <a16:creationId xmlns:a16="http://schemas.microsoft.com/office/drawing/2014/main" id="{417D8FD9-3E8B-4A57-999E-3CE24A3DB30F}"/>
+                <a16:creationId xmlns:a16="http://schemas.microsoft.com/office/drawing/2014/main" id="{BBABC973-08AB-420A-9744-D5BEEAED7E9D}"/>
               </a:ext>
             </a:extLst>
           </p:cNvPr>
@@ -4729,7 +4729,7 @@
           <p:cNvPr id="20" name="">
             <a:extLst xmlns:a="http://schemas.openxmlformats.org/drawingml/2006/main">
               <a:ext uri="{FF2B5EF4-FFF2-40B4-BE49-F238E27FC236}">
-                <a16:creationId xmlns:a16="http://schemas.microsoft.com/office/drawing/2014/main" id="{F0CC3C9A-E6CC-41EB-AC1B-9D605BFD482B}"/>
+                <a16:creationId xmlns:a16="http://schemas.microsoft.com/office/drawing/2014/main" id="{19723A32-191E-4AC9-9792-71DE30583E62}"/>
               </a:ext>
             </a:extLst>
           </p:cNvPr>
@@ -4779,7 +4779,7 @@
           <p:cNvPr id="21" name="">
             <a:extLst xmlns:a="http://schemas.openxmlformats.org/drawingml/2006/main">
               <a:ext uri="{FF2B5EF4-FFF2-40B4-BE49-F238E27FC236}">
-                <a16:creationId xmlns:a16="http://schemas.microsoft.com/office/drawing/2014/main" id="{8031BFCD-B61B-4631-9832-EF69C160455A}"/>
+                <a16:creationId xmlns:a16="http://schemas.microsoft.com/office/drawing/2014/main" id="{660834AD-41D6-4DE6-ABDC-88AF0E45DE4B}"/>
               </a:ext>
             </a:extLst>
           </p:cNvPr>
@@ -4829,7 +4829,7 @@
           <p:cNvPr id="22" name="">
             <a:extLst xmlns:a="http://schemas.openxmlformats.org/drawingml/2006/main">
               <a:ext uri="{FF2B5EF4-FFF2-40B4-BE49-F238E27FC236}">
-                <a16:creationId xmlns:a16="http://schemas.microsoft.com/office/drawing/2014/main" id="{589E1BB8-7420-44DE-BF14-AD50190CCEB7}"/>
+                <a16:creationId xmlns:a16="http://schemas.microsoft.com/office/drawing/2014/main" id="{8958566D-D521-4C0B-B7E3-FC97A84B89BD}"/>
               </a:ext>
             </a:extLst>
           </p:cNvPr>
@@ -4879,7 +4879,7 @@
           <p:cNvPr id="23" name="">
             <a:extLst xmlns:a="http://schemas.openxmlformats.org/drawingml/2006/main">
               <a:ext uri="{FF2B5EF4-FFF2-40B4-BE49-F238E27FC236}">
-                <a16:creationId xmlns:a16="http://schemas.microsoft.com/office/drawing/2014/main" id="{624FD50B-5FE8-4AA1-BCCD-1DECE79008DA}"/>
+                <a16:creationId xmlns:a16="http://schemas.microsoft.com/office/drawing/2014/main" id="{57C8E4C2-EDD1-40C7-9B1C-758519395E81}"/>
               </a:ext>
             </a:extLst>
           </p:cNvPr>
@@ -4929,7 +4929,7 @@
           <p:cNvPr id="24" name="">
             <a:extLst xmlns:a="http://schemas.openxmlformats.org/drawingml/2006/main">
               <a:ext uri="{FF2B5EF4-FFF2-40B4-BE49-F238E27FC236}">
-                <a16:creationId xmlns:a16="http://schemas.microsoft.com/office/drawing/2014/main" id="{DD309DA6-60FE-4DB9-8C84-59E251B5BC7F}"/>
+                <a16:creationId xmlns:a16="http://schemas.microsoft.com/office/drawing/2014/main" id="{8F1C82ED-BBE7-4BC8-B3B9-F01C21AC59AE}"/>
               </a:ext>
             </a:extLst>
           </p:cNvPr>
@@ -4979,7 +4979,7 @@
           <p:cNvPr id="25" name="">
             <a:extLst xmlns:a="http://schemas.openxmlformats.org/drawingml/2006/main">
               <a:ext uri="{FF2B5EF4-FFF2-40B4-BE49-F238E27FC236}">
-                <a16:creationId xmlns:a16="http://schemas.microsoft.com/office/drawing/2014/main" id="{C91DE82F-FE44-4B8C-902F-7487B5252E28}"/>
+                <a16:creationId xmlns:a16="http://schemas.microsoft.com/office/drawing/2014/main" id="{1D017517-2E9C-4B0F-9DA9-31E2323ADB8D}"/>
               </a:ext>
             </a:extLst>
           </p:cNvPr>
@@ -5029,7 +5029,7 @@
           <p:cNvPr id="26" name="">
             <a:extLst xmlns:a="http://schemas.openxmlformats.org/drawingml/2006/main">
               <a:ext uri="{FF2B5EF4-FFF2-40B4-BE49-F238E27FC236}">
-                <a16:creationId xmlns:a16="http://schemas.microsoft.com/office/drawing/2014/main" id="{E39C104E-143C-489E-BC18-D496A59346A5}"/>
+                <a16:creationId xmlns:a16="http://schemas.microsoft.com/office/drawing/2014/main" id="{11515C76-A547-4651-9BD1-24F572148C0A}"/>
               </a:ext>
             </a:extLst>
           </p:cNvPr>
@@ -5079,7 +5079,7 @@
           <p:cNvPr id="27" name="">
             <a:extLst xmlns:a="http://schemas.openxmlformats.org/drawingml/2006/main">
               <a:ext uri="{FF2B5EF4-FFF2-40B4-BE49-F238E27FC236}">
-                <a16:creationId xmlns:a16="http://schemas.microsoft.com/office/drawing/2014/main" id="{870F4136-3AC2-4107-80F1-A667B3A0AC97}"/>
+                <a16:creationId xmlns:a16="http://schemas.microsoft.com/office/drawing/2014/main" id="{4944C233-25FC-4E9F-B595-168615990E01}"/>
               </a:ext>
             </a:extLst>
           </p:cNvPr>
@@ -5129,7 +5129,7 @@
           <p:cNvPr id="28" name="">
             <a:extLst xmlns:a="http://schemas.openxmlformats.org/drawingml/2006/main">
               <a:ext uri="{FF2B5EF4-FFF2-40B4-BE49-F238E27FC236}">
-                <a16:creationId xmlns:a16="http://schemas.microsoft.com/office/drawing/2014/main" id="{022E851F-6738-453D-94AB-656F8BDFD3BB}"/>
+                <a16:creationId xmlns:a16="http://schemas.microsoft.com/office/drawing/2014/main" id="{EEF71DB8-5273-4B1C-9A01-C931E2F79EA7}"/>
               </a:ext>
             </a:extLst>
           </p:cNvPr>
@@ -5179,7 +5179,7 @@
           <p:cNvPr id="29" name="">
             <a:extLst xmlns:a="http://schemas.openxmlformats.org/drawingml/2006/main">
               <a:ext uri="{FF2B5EF4-FFF2-40B4-BE49-F238E27FC236}">
-                <a16:creationId xmlns:a16="http://schemas.microsoft.com/office/drawing/2014/main" id="{FBFD42FA-2920-46C9-8419-71F945F9D66A}"/>
+                <a16:creationId xmlns:a16="http://schemas.microsoft.com/office/drawing/2014/main" id="{92D6C526-7BB9-472C-9846-5B2F5E558BF0}"/>
               </a:ext>
             </a:extLst>
           </p:cNvPr>
@@ -5229,7 +5229,7 @@
           <p:cNvPr id="30" name="">
             <a:extLst xmlns:a="http://schemas.openxmlformats.org/drawingml/2006/main">
               <a:ext uri="{FF2B5EF4-FFF2-40B4-BE49-F238E27FC236}">
-                <a16:creationId xmlns:a16="http://schemas.microsoft.com/office/drawing/2014/main" id="{97F38BF7-6287-4235-9400-CBD129ADC13A}"/>
+                <a16:creationId xmlns:a16="http://schemas.microsoft.com/office/drawing/2014/main" id="{0AA9701F-3271-4B34-B10D-314FB95B875B}"/>
               </a:ext>
             </a:extLst>
           </p:cNvPr>
@@ -5279,7 +5279,7 @@
           <p:cNvPr id="31" name="">
             <a:extLst xmlns:a="http://schemas.openxmlformats.org/drawingml/2006/main">
               <a:ext uri="{FF2B5EF4-FFF2-40B4-BE49-F238E27FC236}">
-                <a16:creationId xmlns:a16="http://schemas.microsoft.com/office/drawing/2014/main" id="{D6A567E6-6F57-4E3D-B5E2-A4F2C867FDC5}"/>
+                <a16:creationId xmlns:a16="http://schemas.microsoft.com/office/drawing/2014/main" id="{7C7061A6-7203-49B4-8A4B-E85ABDCBEE8B}"/>
               </a:ext>
             </a:extLst>
           </p:cNvPr>
@@ -5329,7 +5329,7 @@
           <p:cNvPr id="32" name="">
             <a:extLst xmlns:a="http://schemas.openxmlformats.org/drawingml/2006/main">
               <a:ext uri="{FF2B5EF4-FFF2-40B4-BE49-F238E27FC236}">
-                <a16:creationId xmlns:a16="http://schemas.microsoft.com/office/drawing/2014/main" id="{41D79F7A-726B-4233-BFAD-E106FB69A16C}"/>
+                <a16:creationId xmlns:a16="http://schemas.microsoft.com/office/drawing/2014/main" id="{04D50FDD-907B-4E84-9D02-4E9A9BCE4590}"/>
               </a:ext>
             </a:extLst>
           </p:cNvPr>
@@ -5379,7 +5379,7 @@
           <p:cNvPr id="33" name="">
             <a:extLst xmlns:a="http://schemas.openxmlformats.org/drawingml/2006/main">
               <a:ext uri="{FF2B5EF4-FFF2-40B4-BE49-F238E27FC236}">
-                <a16:creationId xmlns:a16="http://schemas.microsoft.com/office/drawing/2014/main" id="{750DC3A8-FEE0-4486-AB36-3C0D560DFB62}"/>
+                <a16:creationId xmlns:a16="http://schemas.microsoft.com/office/drawing/2014/main" id="{0AA1EF7D-667C-48AF-9C7A-CF3291C59607}"/>
               </a:ext>
             </a:extLst>
           </p:cNvPr>
@@ -5429,7 +5429,7 @@
           <p:cNvPr id="34" name="">
             <a:extLst xmlns:a="http://schemas.openxmlformats.org/drawingml/2006/main">
               <a:ext uri="{FF2B5EF4-FFF2-40B4-BE49-F238E27FC236}">
-                <a16:creationId xmlns:a16="http://schemas.microsoft.com/office/drawing/2014/main" id="{440D2B89-F2C7-42C5-9831-1CC411D02134}"/>
+                <a16:creationId xmlns:a16="http://schemas.microsoft.com/office/drawing/2014/main" id="{C430E4F7-2E1C-47B4-A82A-F11025B23287}"/>
               </a:ext>
             </a:extLst>
           </p:cNvPr>
@@ -5479,7 +5479,7 @@
           <p:cNvPr id="35" name="">
             <a:extLst xmlns:a="http://schemas.openxmlformats.org/drawingml/2006/main">
               <a:ext uri="{FF2B5EF4-FFF2-40B4-BE49-F238E27FC236}">
-                <a16:creationId xmlns:a16="http://schemas.microsoft.com/office/drawing/2014/main" id="{6816F73F-4482-4707-B1D4-767831638CD2}"/>
+                <a16:creationId xmlns:a16="http://schemas.microsoft.com/office/drawing/2014/main" id="{8DA4F1FC-8B53-4DDE-84C6-DDCB5CBA2EEA}"/>
               </a:ext>
             </a:extLst>
           </p:cNvPr>
@@ -5529,7 +5529,7 @@
           <p:cNvPr id="36" name="">
             <a:extLst xmlns:a="http://schemas.openxmlformats.org/drawingml/2006/main">
               <a:ext uri="{FF2B5EF4-FFF2-40B4-BE49-F238E27FC236}">
-                <a16:creationId xmlns:a16="http://schemas.microsoft.com/office/drawing/2014/main" id="{A7328956-0033-482E-9A27-8B8D7907F0CA}"/>
+                <a16:creationId xmlns:a16="http://schemas.microsoft.com/office/drawing/2014/main" id="{2B28FB18-B480-4014-AD50-9F33A36C8127}"/>
               </a:ext>
             </a:extLst>
           </p:cNvPr>
@@ -5579,7 +5579,7 @@
           <p:cNvPr id="37" name="">
             <a:extLst xmlns:a="http://schemas.openxmlformats.org/drawingml/2006/main">
               <a:ext uri="{FF2B5EF4-FFF2-40B4-BE49-F238E27FC236}">
-                <a16:creationId xmlns:a16="http://schemas.microsoft.com/office/drawing/2014/main" id="{9BAAE032-1959-4BCC-9DDE-6D31E4B4097A}"/>
+                <a16:creationId xmlns:a16="http://schemas.microsoft.com/office/drawing/2014/main" id="{F1BF0001-0D16-4B9B-9F75-872BE05740AC}"/>
               </a:ext>
             </a:extLst>
           </p:cNvPr>
@@ -5629,7 +5629,7 @@
           <p:cNvPr id="38" name="">
             <a:extLst xmlns:a="http://schemas.openxmlformats.org/drawingml/2006/main">
               <a:ext uri="{FF2B5EF4-FFF2-40B4-BE49-F238E27FC236}">
-                <a16:creationId xmlns:a16="http://schemas.microsoft.com/office/drawing/2014/main" id="{5196678E-8E4D-4247-AF8D-762FB065AF61}"/>
+                <a16:creationId xmlns:a16="http://schemas.microsoft.com/office/drawing/2014/main" id="{01337D24-C592-4443-9CE0-8950E67BF2C4}"/>
               </a:ext>
             </a:extLst>
           </p:cNvPr>
@@ -5679,7 +5679,7 @@
           <p:cNvPr id="39" name="">
             <a:extLst xmlns:a="http://schemas.openxmlformats.org/drawingml/2006/main">
               <a:ext uri="{FF2B5EF4-FFF2-40B4-BE49-F238E27FC236}">
-                <a16:creationId xmlns:a16="http://schemas.microsoft.com/office/drawing/2014/main" id="{A5407AA2-110A-4F17-BD94-B4E56FCCDB49}"/>
+                <a16:creationId xmlns:a16="http://schemas.microsoft.com/office/drawing/2014/main" id="{9AC8DBF4-06B0-461B-B518-15A91E641D43}"/>
               </a:ext>
             </a:extLst>
           </p:cNvPr>
@@ -5729,7 +5729,7 @@
           <p:cNvPr id="40" name="">
             <a:extLst xmlns:a="http://schemas.openxmlformats.org/drawingml/2006/main">
               <a:ext uri="{FF2B5EF4-FFF2-40B4-BE49-F238E27FC236}">
-                <a16:creationId xmlns:a16="http://schemas.microsoft.com/office/drawing/2014/main" id="{CC559121-D9BC-4817-B329-2D375057F5C4}"/>
+                <a16:creationId xmlns:a16="http://schemas.microsoft.com/office/drawing/2014/main" id="{0D053206-F3B9-4359-BADE-184AA30153E3}"/>
               </a:ext>
             </a:extLst>
           </p:cNvPr>
@@ -5779,7 +5779,7 @@
           <p:cNvPr id="41" name="">
             <a:extLst xmlns:a="http://schemas.openxmlformats.org/drawingml/2006/main">
               <a:ext uri="{FF2B5EF4-FFF2-40B4-BE49-F238E27FC236}">
-                <a16:creationId xmlns:a16="http://schemas.microsoft.com/office/drawing/2014/main" id="{6D578606-274A-4DAA-B8AB-9BA1E46CAFF9}"/>
+                <a16:creationId xmlns:a16="http://schemas.microsoft.com/office/drawing/2014/main" id="{F1250DCE-FF79-4877-B2FC-51C7A878EEF9}"/>
               </a:ext>
             </a:extLst>
           </p:cNvPr>
@@ -5829,7 +5829,7 @@
           <p:cNvPr id="42" name="">
             <a:extLst xmlns:a="http://schemas.openxmlformats.org/drawingml/2006/main">
               <a:ext uri="{FF2B5EF4-FFF2-40B4-BE49-F238E27FC236}">
-                <a16:creationId xmlns:a16="http://schemas.microsoft.com/office/drawing/2014/main" id="{76613269-7E99-461B-B7A8-2AA2017F5168}"/>
+                <a16:creationId xmlns:a16="http://schemas.microsoft.com/office/drawing/2014/main" id="{BDB751D2-C91D-490D-BE1D-E7C6A1E7F095}"/>
               </a:ext>
             </a:extLst>
           </p:cNvPr>
@@ -5879,7 +5879,7 @@
           <p:cNvPr id="43" name="">
             <a:extLst xmlns:a="http://schemas.openxmlformats.org/drawingml/2006/main">
               <a:ext uri="{FF2B5EF4-FFF2-40B4-BE49-F238E27FC236}">
-                <a16:creationId xmlns:a16="http://schemas.microsoft.com/office/drawing/2014/main" id="{69BBFA03-AE17-4A22-9170-B5569F137FD6}"/>
+                <a16:creationId xmlns:a16="http://schemas.microsoft.com/office/drawing/2014/main" id="{DD5BBFE7-B739-4892-8603-D068E9F3FAF6}"/>
               </a:ext>
             </a:extLst>
           </p:cNvPr>
@@ -5929,7 +5929,7 @@
           <p:cNvPr id="44" name="">
             <a:extLst xmlns:a="http://schemas.openxmlformats.org/drawingml/2006/main">
               <a:ext uri="{FF2B5EF4-FFF2-40B4-BE49-F238E27FC236}">
-                <a16:creationId xmlns:a16="http://schemas.microsoft.com/office/drawing/2014/main" id="{821C3D4B-EEBD-4B9F-B0AD-E878332DF9A0}"/>
+                <a16:creationId xmlns:a16="http://schemas.microsoft.com/office/drawing/2014/main" id="{53C75C40-305E-4DD1-B192-0DFD99EB5C6E}"/>
               </a:ext>
             </a:extLst>
           </p:cNvPr>
@@ -5979,7 +5979,7 @@
           <p:cNvPr id="45" name="">
             <a:extLst xmlns:a="http://schemas.openxmlformats.org/drawingml/2006/main">
               <a:ext uri="{FF2B5EF4-FFF2-40B4-BE49-F238E27FC236}">
-                <a16:creationId xmlns:a16="http://schemas.microsoft.com/office/drawing/2014/main" id="{C9463949-F43E-400D-A569-3387A518902A}"/>
+                <a16:creationId xmlns:a16="http://schemas.microsoft.com/office/drawing/2014/main" id="{9EB25F49-E14D-4524-9C77-2C530E92E4AB}"/>
               </a:ext>
             </a:extLst>
           </p:cNvPr>
@@ -6029,7 +6029,7 @@
           <p:cNvPr id="46" name="">
             <a:extLst xmlns:a="http://schemas.openxmlformats.org/drawingml/2006/main">
               <a:ext uri="{FF2B5EF4-FFF2-40B4-BE49-F238E27FC236}">
-                <a16:creationId xmlns:a16="http://schemas.microsoft.com/office/drawing/2014/main" id="{EE640392-57C7-4F74-B90F-1E887B17FFED}"/>
+                <a16:creationId xmlns:a16="http://schemas.microsoft.com/office/drawing/2014/main" id="{119B2624-5D2C-4235-AF43-478123739BBA}"/>
               </a:ext>
             </a:extLst>
           </p:cNvPr>
@@ -6079,7 +6079,7 @@
           <p:cNvPr id="47" name="">
             <a:extLst xmlns:a="http://schemas.openxmlformats.org/drawingml/2006/main">
               <a:ext uri="{FF2B5EF4-FFF2-40B4-BE49-F238E27FC236}">
-                <a16:creationId xmlns:a16="http://schemas.microsoft.com/office/drawing/2014/main" id="{4D4D0498-BA4C-4BB2-B698-020612770642}"/>
+                <a16:creationId xmlns:a16="http://schemas.microsoft.com/office/drawing/2014/main" id="{CD2DB0A8-4919-443B-BDD5-453FDB1C6C95}"/>
               </a:ext>
             </a:extLst>
           </p:cNvPr>
@@ -6129,7 +6129,7 @@
           <p:cNvPr id="48" name="">
             <a:extLst xmlns:a="http://schemas.openxmlformats.org/drawingml/2006/main">
               <a:ext uri="{FF2B5EF4-FFF2-40B4-BE49-F238E27FC236}">
-                <a16:creationId xmlns:a16="http://schemas.microsoft.com/office/drawing/2014/main" id="{8A666674-F308-427D-9016-12345280499A}"/>
+                <a16:creationId xmlns:a16="http://schemas.microsoft.com/office/drawing/2014/main" id="{A7D6BAEB-8702-444F-842E-C6BE162D2E62}"/>
               </a:ext>
             </a:extLst>
           </p:cNvPr>
@@ -6162,7 +6162,7 @@
           <p:cNvPr id="49" name="">
             <a:extLst xmlns:a="http://schemas.openxmlformats.org/drawingml/2006/main">
               <a:ext uri="{FF2B5EF4-FFF2-40B4-BE49-F238E27FC236}">
-                <a16:creationId xmlns:a16="http://schemas.microsoft.com/office/drawing/2014/main" id="{F1F0B4AF-44B8-458D-8746-F8E5686FA715}"/>
+                <a16:creationId xmlns:a16="http://schemas.microsoft.com/office/drawing/2014/main" id="{0D9E2A43-E482-44D3-B4CA-FDD327413A16}"/>
               </a:ext>
             </a:extLst>
           </p:cNvPr>
@@ -6212,7 +6212,7 @@
           <p:cNvPr id="50" name="">
             <a:extLst xmlns:a="http://schemas.openxmlformats.org/drawingml/2006/main">
               <a:ext uri="{FF2B5EF4-FFF2-40B4-BE49-F238E27FC236}">
-                <a16:creationId xmlns:a16="http://schemas.microsoft.com/office/drawing/2014/main" id="{4C98B8A5-F9A7-4DA4-B368-AD67DB6C6FA0}"/>
+                <a16:creationId xmlns:a16="http://schemas.microsoft.com/office/drawing/2014/main" id="{819E603E-AEA2-4F77-B586-616874639F5B}"/>
               </a:ext>
             </a:extLst>
           </p:cNvPr>
@@ -6243,7 +6243,7 @@
           <p:cNvPr id="51" name="">
             <a:extLst xmlns:a="http://schemas.openxmlformats.org/drawingml/2006/main">
               <a:ext uri="{FF2B5EF4-FFF2-40B4-BE49-F238E27FC236}">
-                <a16:creationId xmlns:a16="http://schemas.microsoft.com/office/drawing/2014/main" id="{33EAFB06-5E69-438D-858C-FA3230E83509}"/>
+                <a16:creationId xmlns:a16="http://schemas.microsoft.com/office/drawing/2014/main" id="{C77D0E31-0F59-420E-A227-BCBA02E3A476}"/>
               </a:ext>
             </a:extLst>
           </p:cNvPr>
@@ -6274,7 +6274,7 @@
           <p:cNvPr id="52" name="">
             <a:extLst xmlns:a="http://schemas.openxmlformats.org/drawingml/2006/main">
               <a:ext uri="{FF2B5EF4-FFF2-40B4-BE49-F238E27FC236}">
-                <a16:creationId xmlns:a16="http://schemas.microsoft.com/office/drawing/2014/main" id="{2A82D08A-8CB9-4D5E-96C5-AA17C7CDFC01}"/>
+                <a16:creationId xmlns:a16="http://schemas.microsoft.com/office/drawing/2014/main" id="{E0BB6610-AAAA-4564-BB50-CF44DAF1C269}"/>
               </a:ext>
             </a:extLst>
           </p:cNvPr>
@@ -6305,7 +6305,7 @@
           <p:cNvPr id="53" name="">
             <a:extLst xmlns:a="http://schemas.openxmlformats.org/drawingml/2006/main">
               <a:ext uri="{FF2B5EF4-FFF2-40B4-BE49-F238E27FC236}">
-                <a16:creationId xmlns:a16="http://schemas.microsoft.com/office/drawing/2014/main" id="{6D56D2A5-C27B-433D-BB07-B7B706B50450}"/>
+                <a16:creationId xmlns:a16="http://schemas.microsoft.com/office/drawing/2014/main" id="{66CC56FD-2328-4641-B9FF-51C124088C33}"/>
               </a:ext>
             </a:extLst>
           </p:cNvPr>
@@ -6336,7 +6336,7 @@
           <p:cNvPr id="54" name="">
             <a:extLst xmlns:a="http://schemas.openxmlformats.org/drawingml/2006/main">
               <a:ext uri="{FF2B5EF4-FFF2-40B4-BE49-F238E27FC236}">
-                <a16:creationId xmlns:a16="http://schemas.microsoft.com/office/drawing/2014/main" id="{6D221BE2-31DA-4AA4-8BC4-374FD282F7E3}"/>
+                <a16:creationId xmlns:a16="http://schemas.microsoft.com/office/drawing/2014/main" id="{3890D042-FA60-41E9-A641-0217EB32AE9C}"/>
               </a:ext>
             </a:extLst>
           </p:cNvPr>
@@ -6367,7 +6367,7 @@
           <p:cNvPr id="55" name="">
             <a:extLst xmlns:a="http://schemas.openxmlformats.org/drawingml/2006/main">
               <a:ext uri="{FF2B5EF4-FFF2-40B4-BE49-F238E27FC236}">
-                <a16:creationId xmlns:a16="http://schemas.microsoft.com/office/drawing/2014/main" id="{EBA54974-B89F-4165-B6C4-E9E7A9C554F9}"/>
+                <a16:creationId xmlns:a16="http://schemas.microsoft.com/office/drawing/2014/main" id="{7AA2ED27-1791-4142-BB8D-38E52DD5BB24}"/>
               </a:ext>
             </a:extLst>
           </p:cNvPr>
@@ -6398,7 +6398,7 @@
           <p:cNvPr id="56" name="">
             <a:extLst xmlns:a="http://schemas.openxmlformats.org/drawingml/2006/main">
               <a:ext uri="{FF2B5EF4-FFF2-40B4-BE49-F238E27FC236}">
-                <a16:creationId xmlns:a16="http://schemas.microsoft.com/office/drawing/2014/main" id="{6AE78204-ECFE-47D1-8E1A-4E1D51F2FC04}"/>
+                <a16:creationId xmlns:a16="http://schemas.microsoft.com/office/drawing/2014/main" id="{1D4586F3-A31B-413E-A711-1B1ED063D39B}"/>
               </a:ext>
             </a:extLst>
           </p:cNvPr>
@@ -6429,7 +6429,7 @@
           <p:cNvPr id="57" name="">
             <a:extLst xmlns:a="http://schemas.openxmlformats.org/drawingml/2006/main">
               <a:ext uri="{FF2B5EF4-FFF2-40B4-BE49-F238E27FC236}">
-                <a16:creationId xmlns:a16="http://schemas.microsoft.com/office/drawing/2014/main" id="{E96B3F4A-3E12-4E25-B241-B2CFCC8AD49C}"/>
+                <a16:creationId xmlns:a16="http://schemas.microsoft.com/office/drawing/2014/main" id="{8EA306F9-2FD4-46F2-A2DD-783DB0DE7147}"/>
               </a:ext>
             </a:extLst>
           </p:cNvPr>
@@ -6462,7 +6462,7 @@
           <p:cNvPr id="58" name="">
             <a:extLst xmlns:a="http://schemas.openxmlformats.org/drawingml/2006/main">
               <a:ext uri="{FF2B5EF4-FFF2-40B4-BE49-F238E27FC236}">
-                <a16:creationId xmlns:a16="http://schemas.microsoft.com/office/drawing/2014/main" id="{CC2AA997-A4C9-4502-AF16-A792760B1057}"/>
+                <a16:creationId xmlns:a16="http://schemas.microsoft.com/office/drawing/2014/main" id="{6DE88407-D47D-4F1E-8BC5-78E7FEDD725D}"/>
               </a:ext>
             </a:extLst>
           </p:cNvPr>
@@ -6512,7 +6512,7 @@
           <p:cNvPr id="59" name="">
             <a:extLst xmlns:a="http://schemas.openxmlformats.org/drawingml/2006/main">
               <a:ext uri="{FF2B5EF4-FFF2-40B4-BE49-F238E27FC236}">
-                <a16:creationId xmlns:a16="http://schemas.microsoft.com/office/drawing/2014/main" id="{F8F14FB3-3934-4FAE-895C-A06E8E05AE6A}"/>
+                <a16:creationId xmlns:a16="http://schemas.microsoft.com/office/drawing/2014/main" id="{92F2588F-47E5-44A8-B8BE-07C634EE87E1}"/>
               </a:ext>
             </a:extLst>
           </p:cNvPr>
@@ -6545,7 +6545,7 @@
           <p:cNvPr id="60" name="">
             <a:extLst xmlns:a="http://schemas.openxmlformats.org/drawingml/2006/main">
               <a:ext uri="{FF2B5EF4-FFF2-40B4-BE49-F238E27FC236}">
-                <a16:creationId xmlns:a16="http://schemas.microsoft.com/office/drawing/2014/main" id="{448C4741-DBB6-4401-B1DF-3CF621AB8223}"/>
+                <a16:creationId xmlns:a16="http://schemas.microsoft.com/office/drawing/2014/main" id="{D2E0B1FC-CFB0-4150-A44D-ADD00969209B}"/>
               </a:ext>
             </a:extLst>
           </p:cNvPr>
@@ -6595,7 +6595,7 @@
           <p:cNvPr id="61" name="">
             <a:extLst xmlns:a="http://schemas.openxmlformats.org/drawingml/2006/main">
               <a:ext uri="{FF2B5EF4-FFF2-40B4-BE49-F238E27FC236}">
-                <a16:creationId xmlns:a16="http://schemas.microsoft.com/office/drawing/2014/main" id="{AC7A4AA3-CA36-4AD9-9F19-25738F148AEB}"/>
+                <a16:creationId xmlns:a16="http://schemas.microsoft.com/office/drawing/2014/main" id="{F82C98EA-7155-4322-89D2-2CE811CF8ACA}"/>
               </a:ext>
             </a:extLst>
           </p:cNvPr>
@@ -6628,7 +6628,7 @@
           <p:cNvPr id="62" name="">
             <a:extLst xmlns:a="http://schemas.openxmlformats.org/drawingml/2006/main">
               <a:ext uri="{FF2B5EF4-FFF2-40B4-BE49-F238E27FC236}">
-                <a16:creationId xmlns:a16="http://schemas.microsoft.com/office/drawing/2014/main" id="{F76AE509-9BFB-4EE2-A539-D8DB7A115F86}"/>
+                <a16:creationId xmlns:a16="http://schemas.microsoft.com/office/drawing/2014/main" id="{8159C1C8-B7E1-499B-A993-CBBADD4AA99B}"/>
               </a:ext>
             </a:extLst>
           </p:cNvPr>
@@ -6678,7 +6678,7 @@
           <p:cNvPr id="63" name="">
             <a:extLst xmlns:a="http://schemas.openxmlformats.org/drawingml/2006/main">
               <a:ext uri="{FF2B5EF4-FFF2-40B4-BE49-F238E27FC236}">
-                <a16:creationId xmlns:a16="http://schemas.microsoft.com/office/drawing/2014/main" id="{05DB967E-A21C-4D60-90A3-CB0B0364FAB9}"/>
+                <a16:creationId xmlns:a16="http://schemas.microsoft.com/office/drawing/2014/main" id="{0240C1DB-7FA5-495E-A91E-E290CAC14F23}"/>
               </a:ext>
             </a:extLst>
           </p:cNvPr>
@@ -6711,7 +6711,7 @@
           <p:cNvPr id="64" name="">
             <a:extLst xmlns:a="http://schemas.openxmlformats.org/drawingml/2006/main">
               <a:ext uri="{FF2B5EF4-FFF2-40B4-BE49-F238E27FC236}">
-                <a16:creationId xmlns:a16="http://schemas.microsoft.com/office/drawing/2014/main" id="{8566F25C-49AC-41FF-B550-E65C05503EBC}"/>
+                <a16:creationId xmlns:a16="http://schemas.microsoft.com/office/drawing/2014/main" id="{19AE896A-5480-4CEA-AB32-670913EE6F56}"/>
               </a:ext>
             </a:extLst>
           </p:cNvPr>
@@ -6761,7 +6761,7 @@
           <p:cNvPr id="65" name="">
             <a:extLst xmlns:a="http://schemas.openxmlformats.org/drawingml/2006/main">
               <a:ext uri="{FF2B5EF4-FFF2-40B4-BE49-F238E27FC236}">
-                <a16:creationId xmlns:a16="http://schemas.microsoft.com/office/drawing/2014/main" id="{D06AFAB0-F5E4-4FCF-AE96-9E1C7572DDAB}"/>
+                <a16:creationId xmlns:a16="http://schemas.microsoft.com/office/drawing/2014/main" id="{A2BA36DC-FA53-4FD0-AF5E-7161EE37261A}"/>
               </a:ext>
             </a:extLst>
           </p:cNvPr>
@@ -6794,7 +6794,7 @@
           <p:cNvPr id="66" name="">
             <a:extLst xmlns:a="http://schemas.openxmlformats.org/drawingml/2006/main">
               <a:ext uri="{FF2B5EF4-FFF2-40B4-BE49-F238E27FC236}">
-                <a16:creationId xmlns:a16="http://schemas.microsoft.com/office/drawing/2014/main" id="{D2FE8534-93D8-4395-BB1B-C911E54501D6}"/>
+                <a16:creationId xmlns:a16="http://schemas.microsoft.com/office/drawing/2014/main" id="{5CD11C40-BBA8-4BCD-8485-70995AF1A70A}"/>
               </a:ext>
             </a:extLst>
           </p:cNvPr>
@@ -6844,7 +6844,7 @@
           <p:cNvPr id="67" name="">
             <a:extLst xmlns:a="http://schemas.openxmlformats.org/drawingml/2006/main">
               <a:ext uri="{FF2B5EF4-FFF2-40B4-BE49-F238E27FC236}">
-                <a16:creationId xmlns:a16="http://schemas.microsoft.com/office/drawing/2014/main" id="{7BC6F923-9EFF-469A-A701-33B3C990DBD8}"/>
+                <a16:creationId xmlns:a16="http://schemas.microsoft.com/office/drawing/2014/main" id="{FFBA075A-5FF4-4736-B799-0ADD49BAC825}"/>
               </a:ext>
             </a:extLst>
           </p:cNvPr>
@@ -6877,7 +6877,7 @@
           <p:cNvPr id="68" name="">
             <a:extLst xmlns:a="http://schemas.openxmlformats.org/drawingml/2006/main">
               <a:ext uri="{FF2B5EF4-FFF2-40B4-BE49-F238E27FC236}">
-                <a16:creationId xmlns:a16="http://schemas.microsoft.com/office/drawing/2014/main" id="{79AC2323-DD0C-406C-A194-6646AD358B9D}"/>
+                <a16:creationId xmlns:a16="http://schemas.microsoft.com/office/drawing/2014/main" id="{38FE9F3B-821B-40CA-BEE5-EB567F82DFA0}"/>
               </a:ext>
             </a:extLst>
           </p:cNvPr>
@@ -6927,7 +6927,7 @@
           <p:cNvPr id="69" name="">
             <a:extLst xmlns:a="http://schemas.openxmlformats.org/drawingml/2006/main">
               <a:ext uri="{FF2B5EF4-FFF2-40B4-BE49-F238E27FC236}">
-                <a16:creationId xmlns:a16="http://schemas.microsoft.com/office/drawing/2014/main" id="{07D07804-096D-405A-BBB7-31B5CA428E4D}"/>
+                <a16:creationId xmlns:a16="http://schemas.microsoft.com/office/drawing/2014/main" id="{334B4920-A524-4C85-A94D-8C35C50020AD}"/>
               </a:ext>
             </a:extLst>
           </p:cNvPr>
@@ -6960,7 +6960,7 @@
           <p:cNvPr id="70" name="">
             <a:extLst xmlns:a="http://schemas.openxmlformats.org/drawingml/2006/main">
               <a:ext uri="{FF2B5EF4-FFF2-40B4-BE49-F238E27FC236}">
-                <a16:creationId xmlns:a16="http://schemas.microsoft.com/office/drawing/2014/main" id="{9C02A4B5-C3D4-4CF3-952D-A4FEDB7036D4}"/>
+                <a16:creationId xmlns:a16="http://schemas.microsoft.com/office/drawing/2014/main" id="{946E8091-5F8C-4642-81B3-447A4BC8E8DD}"/>
               </a:ext>
             </a:extLst>
           </p:cNvPr>
@@ -7010,7 +7010,7 @@
           <p:cNvPr id="71" name="">
             <a:extLst xmlns:a="http://schemas.openxmlformats.org/drawingml/2006/main">
               <a:ext uri="{FF2B5EF4-FFF2-40B4-BE49-F238E27FC236}">
-                <a16:creationId xmlns:a16="http://schemas.microsoft.com/office/drawing/2014/main" id="{59F19185-7863-47A9-AFF9-9AB6577E420C}"/>
+                <a16:creationId xmlns:a16="http://schemas.microsoft.com/office/drawing/2014/main" id="{5D799516-DEE9-4ABF-B4E3-714AEA185EFF}"/>
               </a:ext>
             </a:extLst>
           </p:cNvPr>
@@ -7058,7 +7058,7 @@
     </p:spTree>
     <p:extLst>
       <p:ext uri="{BB962C8B-B14F-4D97-AF65-F5344CB8AC3E}">
-        <p14:creationId xmlns:p14="http://schemas.microsoft.com/office/powerpoint/2010/main" val="157589790"/>
+        <p14:creationId xmlns:p14="http://schemas.microsoft.com/office/powerpoint/2010/main" val="1697540479"/>
       </p:ext>
     </p:extLst>
   </p:cSld>
@@ -7089,7 +7089,7 @@
           <p:cNvPr id="12" name="slide-5-title">
             <a:extLst xmlns:a="http://schemas.openxmlformats.org/drawingml/2006/main">
               <a:ext uri="{FF2B5EF4-FFF2-40B4-BE49-F238E27FC236}">
-                <a16:creationId xmlns:a16="http://schemas.microsoft.com/office/drawing/2014/main" id="{C3634FEA-2B48-45FD-9D31-2F7CE1F3573C}"/>
+                <a16:creationId xmlns:a16="http://schemas.microsoft.com/office/drawing/2014/main" id="{EC4F283E-81D3-46DF-A7CA-A688D06D5A31}"/>
               </a:ext>
             </a:extLst>
           </p:cNvPr>
@@ -7139,7 +7139,7 @@
           <p:cNvPr id="2" name="slide-5-subtitle">
             <a:extLst xmlns:a="http://schemas.openxmlformats.org/drawingml/2006/main">
               <a:ext uri="{FF2B5EF4-FFF2-40B4-BE49-F238E27FC236}">
-                <a16:creationId xmlns:a16="http://schemas.microsoft.com/office/drawing/2014/main" id="{097A4488-1455-4DED-89E7-1EFEA0ED8BCF}"/>
+                <a16:creationId xmlns:a16="http://schemas.microsoft.com/office/drawing/2014/main" id="{F5EC8C71-2A3E-4ECE-AF36-770CA2864C90}"/>
               </a:ext>
             </a:extLst>
           </p:cNvPr>
@@ -7189,7 +7189,7 @@
           <p:cNvPr id="3" name="slide-5-footer">
             <a:extLst xmlns:a="http://schemas.openxmlformats.org/drawingml/2006/main">
               <a:ext uri="{FF2B5EF4-FFF2-40B4-BE49-F238E27FC236}">
-                <a16:creationId xmlns:a16="http://schemas.microsoft.com/office/drawing/2014/main" id="{C24C5950-29F7-4036-8495-DBFE59CB2E65}"/>
+                <a16:creationId xmlns:a16="http://schemas.microsoft.com/office/drawing/2014/main" id="{392F8B77-BDC3-475B-9EAB-40D6F9294E78}"/>
               </a:ext>
             </a:extLst>
           </p:cNvPr>
@@ -7246,7 +7246,7 @@
         </p:xfrm>
         <a:graphic xmlns:a="http://schemas.openxmlformats.org/drawingml/2006/main">
           <a:graphicData uri="http://schemas.openxmlformats.org/drawingml/2006/chart">
-            <c:chart xmlns:r="http://schemas.openxmlformats.org/officeDocument/2006/relationships" xmlns:c="http://schemas.openxmlformats.org/drawingml/2006/chart" r:id="R59954dd4d04549e9"/>
+            <c:chart xmlns:r="http://schemas.openxmlformats.org/officeDocument/2006/relationships" xmlns:c="http://schemas.openxmlformats.org/drawingml/2006/chart" r:id="R70ab8fe9aca3436e"/>
           </a:graphicData>
         </a:graphic>
       </p:graphicFrame>
@@ -7255,7 +7255,7 @@
           <p:cNvPr id="5" name="">
             <a:extLst xmlns:a="http://schemas.openxmlformats.org/drawingml/2006/main">
               <a:ext uri="{FF2B5EF4-FFF2-40B4-BE49-F238E27FC236}">
-                <a16:creationId xmlns:a16="http://schemas.microsoft.com/office/drawing/2014/main" id="{78974AA8-A2D3-45F8-A865-EF20820B2499}"/>
+                <a16:creationId xmlns:a16="http://schemas.microsoft.com/office/drawing/2014/main" id="{A4C9D1CA-079A-4654-99DA-7DD7B5188BC3}"/>
               </a:ext>
             </a:extLst>
           </p:cNvPr>
@@ -7286,7 +7286,7 @@
           <p:cNvPr id="6" name="">
             <a:extLst xmlns:a="http://schemas.openxmlformats.org/drawingml/2006/main">
               <a:ext uri="{FF2B5EF4-FFF2-40B4-BE49-F238E27FC236}">
-                <a16:creationId xmlns:a16="http://schemas.microsoft.com/office/drawing/2014/main" id="{4ADA41E3-1D94-42C4-92F5-DFB286EF0CF2}"/>
+                <a16:creationId xmlns:a16="http://schemas.microsoft.com/office/drawing/2014/main" id="{CC331160-1763-41A9-9BDD-04888E2B15A0}"/>
               </a:ext>
             </a:extLst>
           </p:cNvPr>
@@ -7336,7 +7336,7 @@
           <p:cNvPr id="7" name="">
             <a:extLst xmlns:a="http://schemas.openxmlformats.org/drawingml/2006/main">
               <a:ext uri="{FF2B5EF4-FFF2-40B4-BE49-F238E27FC236}">
-                <a16:creationId xmlns:a16="http://schemas.microsoft.com/office/drawing/2014/main" id="{A1C368C2-764B-4D2E-9879-6C5DDC02CDF9}"/>
+                <a16:creationId xmlns:a16="http://schemas.microsoft.com/office/drawing/2014/main" id="{3259B595-89CB-435B-94C4-AE37C23F91A1}"/>
               </a:ext>
             </a:extLst>
           </p:cNvPr>
@@ -7386,7 +7386,7 @@
           <p:cNvPr id="8" name="">
             <a:extLst xmlns:a="http://schemas.openxmlformats.org/drawingml/2006/main">
               <a:ext uri="{FF2B5EF4-FFF2-40B4-BE49-F238E27FC236}">
-                <a16:creationId xmlns:a16="http://schemas.microsoft.com/office/drawing/2014/main" id="{ADB19D89-A5A2-4006-9CED-B7079B3B3957}"/>
+                <a16:creationId xmlns:a16="http://schemas.microsoft.com/office/drawing/2014/main" id="{F5D899B8-9373-499F-9116-40C33DF2331B}"/>
               </a:ext>
             </a:extLst>
           </p:cNvPr>
@@ -7417,7 +7417,7 @@
           <p:cNvPr id="9" name="">
             <a:extLst xmlns:a="http://schemas.openxmlformats.org/drawingml/2006/main">
               <a:ext uri="{FF2B5EF4-FFF2-40B4-BE49-F238E27FC236}">
-                <a16:creationId xmlns:a16="http://schemas.microsoft.com/office/drawing/2014/main" id="{403666C9-6951-4374-ACAD-9C7EAB6AD262}"/>
+                <a16:creationId xmlns:a16="http://schemas.microsoft.com/office/drawing/2014/main" id="{9ADABB62-E2D4-4D54-A3B3-CA3F5DF724F7}"/>
               </a:ext>
             </a:extLst>
           </p:cNvPr>
@@ -7467,7 +7467,7 @@
           <p:cNvPr id="10" name="">
             <a:extLst xmlns:a="http://schemas.openxmlformats.org/drawingml/2006/main">
               <a:ext uri="{FF2B5EF4-FFF2-40B4-BE49-F238E27FC236}">
-                <a16:creationId xmlns:a16="http://schemas.microsoft.com/office/drawing/2014/main" id="{222CC0FC-DD82-4563-9BCC-568920116A51}"/>
+                <a16:creationId xmlns:a16="http://schemas.microsoft.com/office/drawing/2014/main" id="{6379EDF6-0A43-4B2C-9C67-6C6D10ABE3C7}"/>
               </a:ext>
             </a:extLst>
           </p:cNvPr>
@@ -7517,7 +7517,7 @@
           <p:cNvPr id="11" name="">
             <a:extLst xmlns:a="http://schemas.openxmlformats.org/drawingml/2006/main">
               <a:ext uri="{FF2B5EF4-FFF2-40B4-BE49-F238E27FC236}">
-                <a16:creationId xmlns:a16="http://schemas.microsoft.com/office/drawing/2014/main" id="{D249A5CD-63FA-42BE-A52E-02987E9A6D52}"/>
+                <a16:creationId xmlns:a16="http://schemas.microsoft.com/office/drawing/2014/main" id="{E8BAD1C4-8E7E-40DE-99B0-26FC3F149F80}"/>
               </a:ext>
             </a:extLst>
           </p:cNvPr>
@@ -7565,7 +7565,7 @@
     </p:spTree>
     <p:extLst>
       <p:ext uri="{BB962C8B-B14F-4D97-AF65-F5344CB8AC3E}">
-        <p14:creationId xmlns:p14="http://schemas.microsoft.com/office/powerpoint/2010/main" val="1635614090"/>
+        <p14:creationId xmlns:p14="http://schemas.microsoft.com/office/powerpoint/2010/main" val="1757253413"/>
       </p:ext>
     </p:extLst>
   </p:cSld>
@@ -7596,7 +7596,7 @@
           <p:cNvPr id="55" name="slide-6-title">
             <a:extLst xmlns:a="http://schemas.openxmlformats.org/drawingml/2006/main">
               <a:ext uri="{FF2B5EF4-FFF2-40B4-BE49-F238E27FC236}">
-                <a16:creationId xmlns:a16="http://schemas.microsoft.com/office/drawing/2014/main" id="{03BD7BCF-CEDC-4267-89CE-17146B79B68D}"/>
+                <a16:creationId xmlns:a16="http://schemas.microsoft.com/office/drawing/2014/main" id="{D78D8CF2-1FD9-4ECC-BFD9-AB6E296A7998}"/>
               </a:ext>
             </a:extLst>
           </p:cNvPr>
@@ -7646,7 +7646,7 @@
           <p:cNvPr id="2" name="slide-6-subtitle">
             <a:extLst xmlns:a="http://schemas.openxmlformats.org/drawingml/2006/main">
               <a:ext uri="{FF2B5EF4-FFF2-40B4-BE49-F238E27FC236}">
-                <a16:creationId xmlns:a16="http://schemas.microsoft.com/office/drawing/2014/main" id="{B8AC3867-A9F3-4981-AB47-F5D83FFAFD69}"/>
+                <a16:creationId xmlns:a16="http://schemas.microsoft.com/office/drawing/2014/main" id="{4856C3F7-5D96-4ECE-872B-5D67E9AF339B}"/>
               </a:ext>
             </a:extLst>
           </p:cNvPr>
@@ -7696,7 +7696,7 @@
           <p:cNvPr id="3" name="slide-6-footer">
             <a:extLst xmlns:a="http://schemas.openxmlformats.org/drawingml/2006/main">
               <a:ext uri="{FF2B5EF4-FFF2-40B4-BE49-F238E27FC236}">
-                <a16:creationId xmlns:a16="http://schemas.microsoft.com/office/drawing/2014/main" id="{05CD85F1-0515-4F99-BC7C-378920856F2F}"/>
+                <a16:creationId xmlns:a16="http://schemas.microsoft.com/office/drawing/2014/main" id="{CEE5A6EC-FA40-4D15-99ED-CB2CD166E48B}"/>
               </a:ext>
             </a:extLst>
           </p:cNvPr>
@@ -7746,7 +7746,7 @@
           <p:cNvPr id="4" name="">
             <a:extLst xmlns:a="http://schemas.openxmlformats.org/drawingml/2006/main">
               <a:ext uri="{FF2B5EF4-FFF2-40B4-BE49-F238E27FC236}">
-                <a16:creationId xmlns:a16="http://schemas.microsoft.com/office/drawing/2014/main" id="{32D08259-2FDF-48CF-9A53-DE2ADB7F6E1D}"/>
+                <a16:creationId xmlns:a16="http://schemas.microsoft.com/office/drawing/2014/main" id="{F4D0CBCE-6FF0-4FBB-8AA6-249C86D0F049}"/>
               </a:ext>
             </a:extLst>
           </p:cNvPr>
@@ -7777,7 +7777,7 @@
           <p:cNvPr id="5" name="">
             <a:extLst xmlns:a="http://schemas.openxmlformats.org/drawingml/2006/main">
               <a:ext uri="{FF2B5EF4-FFF2-40B4-BE49-F238E27FC236}">
-                <a16:creationId xmlns:a16="http://schemas.microsoft.com/office/drawing/2014/main" id="{C5D43FBA-F1EF-4CE7-91B8-D725B3AC3AF4}"/>
+                <a16:creationId xmlns:a16="http://schemas.microsoft.com/office/drawing/2014/main" id="{7A238820-95B2-46C7-BEBB-B531B7222A66}"/>
               </a:ext>
             </a:extLst>
           </p:cNvPr>
@@ -7827,7 +7827,7 @@
           <p:cNvPr id="6" name="">
             <a:extLst xmlns:a="http://schemas.openxmlformats.org/drawingml/2006/main">
               <a:ext uri="{FF2B5EF4-FFF2-40B4-BE49-F238E27FC236}">
-                <a16:creationId xmlns:a16="http://schemas.microsoft.com/office/drawing/2014/main" id="{F6AC68CE-630E-4D6A-A5D8-2E010518FBA4}"/>
+                <a16:creationId xmlns:a16="http://schemas.microsoft.com/office/drawing/2014/main" id="{E2092613-A893-49B9-853D-E0FF7975EA4D}"/>
               </a:ext>
             </a:extLst>
           </p:cNvPr>
@@ -7877,7 +7877,7 @@
           <p:cNvPr id="7" name="">
             <a:extLst xmlns:a="http://schemas.openxmlformats.org/drawingml/2006/main">
               <a:ext uri="{FF2B5EF4-FFF2-40B4-BE49-F238E27FC236}">
-                <a16:creationId xmlns:a16="http://schemas.microsoft.com/office/drawing/2014/main" id="{8DB026B2-80B2-49C5-A9E8-42CCE4165A8B}"/>
+                <a16:creationId xmlns:a16="http://schemas.microsoft.com/office/drawing/2014/main" id="{D990FEE5-758C-429D-98F1-E90256DAA5B7}"/>
               </a:ext>
             </a:extLst>
           </p:cNvPr>
@@ -7908,7 +7908,7 @@
           <p:cNvPr id="8" name="">
             <a:extLst xmlns:a="http://schemas.openxmlformats.org/drawingml/2006/main">
               <a:ext uri="{FF2B5EF4-FFF2-40B4-BE49-F238E27FC236}">
-                <a16:creationId xmlns:a16="http://schemas.microsoft.com/office/drawing/2014/main" id="{67D4703B-7A2C-4CE7-BFBB-C88645A4BA21}"/>
+                <a16:creationId xmlns:a16="http://schemas.microsoft.com/office/drawing/2014/main" id="{2CCA0CFA-5FDD-42B0-A437-A5A96EF36DF1}"/>
               </a:ext>
             </a:extLst>
           </p:cNvPr>
@@ -7958,7 +7958,7 @@
           <p:cNvPr id="9" name="">
             <a:extLst xmlns:a="http://schemas.openxmlformats.org/drawingml/2006/main">
               <a:ext uri="{FF2B5EF4-FFF2-40B4-BE49-F238E27FC236}">
-                <a16:creationId xmlns:a16="http://schemas.microsoft.com/office/drawing/2014/main" id="{32015B5A-FB03-4E87-AB44-55C80F864C54}"/>
+                <a16:creationId xmlns:a16="http://schemas.microsoft.com/office/drawing/2014/main" id="{28E6D6C1-3E99-4D93-B9B2-042B32D20DFA}"/>
               </a:ext>
             </a:extLst>
           </p:cNvPr>
@@ -8008,7 +8008,7 @@
           <p:cNvPr id="10" name="">
             <a:extLst xmlns:a="http://schemas.openxmlformats.org/drawingml/2006/main">
               <a:ext uri="{FF2B5EF4-FFF2-40B4-BE49-F238E27FC236}">
-                <a16:creationId xmlns:a16="http://schemas.microsoft.com/office/drawing/2014/main" id="{65F559C2-E892-47E3-B140-191572298B3B}"/>
+                <a16:creationId xmlns:a16="http://schemas.microsoft.com/office/drawing/2014/main" id="{7C76E4E4-4801-4839-A403-7DA80ED66331}"/>
               </a:ext>
             </a:extLst>
           </p:cNvPr>
@@ -8039,7 +8039,7 @@
           <p:cNvPr id="11" name="">
             <a:extLst xmlns:a="http://schemas.openxmlformats.org/drawingml/2006/main">
               <a:ext uri="{FF2B5EF4-FFF2-40B4-BE49-F238E27FC236}">
-                <a16:creationId xmlns:a16="http://schemas.microsoft.com/office/drawing/2014/main" id="{DC4DB35E-14D0-4261-840B-53DDB3F3DD0D}"/>
+                <a16:creationId xmlns:a16="http://schemas.microsoft.com/office/drawing/2014/main" id="{5E8E13CA-7C1D-4DAF-9587-1DF1A59B3E7A}"/>
               </a:ext>
             </a:extLst>
           </p:cNvPr>
@@ -8089,7 +8089,7 @@
           <p:cNvPr id="12" name="">
             <a:extLst xmlns:a="http://schemas.openxmlformats.org/drawingml/2006/main">
               <a:ext uri="{FF2B5EF4-FFF2-40B4-BE49-F238E27FC236}">
-                <a16:creationId xmlns:a16="http://schemas.microsoft.com/office/drawing/2014/main" id="{4C7BD2CF-81A2-47F3-9D14-2929703709F2}"/>
+                <a16:creationId xmlns:a16="http://schemas.microsoft.com/office/drawing/2014/main" id="{FC4EF6F9-E4C6-4E05-BCEC-8602F4450A80}"/>
               </a:ext>
             </a:extLst>
           </p:cNvPr>
@@ -8139,7 +8139,7 @@
           <p:cNvPr id="13" name="">
             <a:extLst xmlns:a="http://schemas.openxmlformats.org/drawingml/2006/main">
               <a:ext uri="{FF2B5EF4-FFF2-40B4-BE49-F238E27FC236}">
-                <a16:creationId xmlns:a16="http://schemas.microsoft.com/office/drawing/2014/main" id="{328845CB-E14B-43DB-AA6B-F8DEAC210838}"/>
+                <a16:creationId xmlns:a16="http://schemas.microsoft.com/office/drawing/2014/main" id="{FF16A733-03F3-4A92-89B3-3AA9B38C7E97}"/>
               </a:ext>
             </a:extLst>
           </p:cNvPr>
@@ -8170,7 +8170,7 @@
           <p:cNvPr id="14" name="">
             <a:extLst xmlns:a="http://schemas.openxmlformats.org/drawingml/2006/main">
               <a:ext uri="{FF2B5EF4-FFF2-40B4-BE49-F238E27FC236}">
-                <a16:creationId xmlns:a16="http://schemas.microsoft.com/office/drawing/2014/main" id="{F2220A9A-2279-4ED4-89AF-0E2A64DD0470}"/>
+                <a16:creationId xmlns:a16="http://schemas.microsoft.com/office/drawing/2014/main" id="{D4CF35EB-FD0A-4525-87BD-920BCD4CA4F5}"/>
               </a:ext>
             </a:extLst>
           </p:cNvPr>
@@ -8220,7 +8220,7 @@
           <p:cNvPr id="15" name="">
             <a:extLst xmlns:a="http://schemas.openxmlformats.org/drawingml/2006/main">
               <a:ext uri="{FF2B5EF4-FFF2-40B4-BE49-F238E27FC236}">
-                <a16:creationId xmlns:a16="http://schemas.microsoft.com/office/drawing/2014/main" id="{DF51B0FB-C8B2-4FCE-AACE-85880558CB4E}"/>
+                <a16:creationId xmlns:a16="http://schemas.microsoft.com/office/drawing/2014/main" id="{DD0613DA-D824-4595-A5C5-A1116A4BE01C}"/>
               </a:ext>
             </a:extLst>
           </p:cNvPr>
@@ -8277,7 +8277,7 @@
         </p:xfrm>
         <a:graphic xmlns:a="http://schemas.openxmlformats.org/drawingml/2006/main">
           <a:graphicData uri="http://schemas.openxmlformats.org/drawingml/2006/chart">
-            <c:chart xmlns:r="http://schemas.openxmlformats.org/officeDocument/2006/relationships" xmlns:c="http://schemas.openxmlformats.org/drawingml/2006/chart" r:id="R4cb6bf132e9643d6"/>
+            <c:chart xmlns:r="http://schemas.openxmlformats.org/officeDocument/2006/relationships" xmlns:c="http://schemas.openxmlformats.org/drawingml/2006/chart" r:id="Rb536fdf18b084ef2"/>
           </a:graphicData>
         </a:graphic>
       </p:graphicFrame>
@@ -8286,7 +8286,7 @@
           <p:cNvPr id="17" name="">
             <a:extLst xmlns:a="http://schemas.openxmlformats.org/drawingml/2006/main">
               <a:ext uri="{FF2B5EF4-FFF2-40B4-BE49-F238E27FC236}">
-                <a16:creationId xmlns:a16="http://schemas.microsoft.com/office/drawing/2014/main" id="{DF5B8090-F97D-4201-876D-485ACB2AA0EA}"/>
+                <a16:creationId xmlns:a16="http://schemas.microsoft.com/office/drawing/2014/main" id="{5691D8CC-544B-4FF8-A045-3229137134D3}"/>
               </a:ext>
             </a:extLst>
           </p:cNvPr>
@@ -8319,7 +8319,7 @@
           <p:cNvPr id="18" name="">
             <a:extLst xmlns:a="http://schemas.openxmlformats.org/drawingml/2006/main">
               <a:ext uri="{FF2B5EF4-FFF2-40B4-BE49-F238E27FC236}">
-                <a16:creationId xmlns:a16="http://schemas.microsoft.com/office/drawing/2014/main" id="{E39C709C-1498-41EB-A79C-76009A891F8D}"/>
+                <a16:creationId xmlns:a16="http://schemas.microsoft.com/office/drawing/2014/main" id="{2B026DCD-96E3-4E77-B98D-3120C7B33FAC}"/>
               </a:ext>
             </a:extLst>
           </p:cNvPr>
@@ -8350,7 +8350,7 @@
           <p:cNvPr id="19" name="">
             <a:extLst xmlns:a="http://schemas.openxmlformats.org/drawingml/2006/main">
               <a:ext uri="{FF2B5EF4-FFF2-40B4-BE49-F238E27FC236}">
-                <a16:creationId xmlns:a16="http://schemas.microsoft.com/office/drawing/2014/main" id="{174A89F9-19F9-40BB-8159-221BE7090D1D}"/>
+                <a16:creationId xmlns:a16="http://schemas.microsoft.com/office/drawing/2014/main" id="{21BE2906-33C2-4C5F-979A-C8C52F23878C}"/>
               </a:ext>
             </a:extLst>
           </p:cNvPr>
@@ -8381,7 +8381,7 @@
           <p:cNvPr id="20" name="">
             <a:extLst xmlns:a="http://schemas.openxmlformats.org/drawingml/2006/main">
               <a:ext uri="{FF2B5EF4-FFF2-40B4-BE49-F238E27FC236}">
-                <a16:creationId xmlns:a16="http://schemas.microsoft.com/office/drawing/2014/main" id="{E1625C07-55C6-4F43-97EE-8A86751A0B3D}"/>
+                <a16:creationId xmlns:a16="http://schemas.microsoft.com/office/drawing/2014/main" id="{ADE21273-D6CB-463B-B930-879BB5618F9E}"/>
               </a:ext>
             </a:extLst>
           </p:cNvPr>
@@ -8412,7 +8412,7 @@
           <p:cNvPr id="21" name="">
             <a:extLst xmlns:a="http://schemas.openxmlformats.org/drawingml/2006/main">
               <a:ext uri="{FF2B5EF4-FFF2-40B4-BE49-F238E27FC236}">
-                <a16:creationId xmlns:a16="http://schemas.microsoft.com/office/drawing/2014/main" id="{5A002A77-D950-43F9-A3D6-92ACD089C60D}"/>
+                <a16:creationId xmlns:a16="http://schemas.microsoft.com/office/drawing/2014/main" id="{13ECB605-F056-4A20-AAAD-F7EAA11E250E}"/>
               </a:ext>
             </a:extLst>
           </p:cNvPr>
@@ -8443,7 +8443,7 @@
           <p:cNvPr id="22" name="">
             <a:extLst xmlns:a="http://schemas.openxmlformats.org/drawingml/2006/main">
               <a:ext uri="{FF2B5EF4-FFF2-40B4-BE49-F238E27FC236}">
-                <a16:creationId xmlns:a16="http://schemas.microsoft.com/office/drawing/2014/main" id="{6DD84914-E83F-4D58-9EE0-289636FE5F87}"/>
+                <a16:creationId xmlns:a16="http://schemas.microsoft.com/office/drawing/2014/main" id="{D39901FF-B4D5-48B1-B335-8A6610323F9F}"/>
               </a:ext>
             </a:extLst>
           </p:cNvPr>
@@ -8474,7 +8474,7 @@
           <p:cNvPr id="23" name="">
             <a:extLst xmlns:a="http://schemas.openxmlformats.org/drawingml/2006/main">
               <a:ext uri="{FF2B5EF4-FFF2-40B4-BE49-F238E27FC236}">
-                <a16:creationId xmlns:a16="http://schemas.microsoft.com/office/drawing/2014/main" id="{658D0459-8E76-4768-AF70-AB7F5160337A}"/>
+                <a16:creationId xmlns:a16="http://schemas.microsoft.com/office/drawing/2014/main" id="{189D8B9F-5517-4068-AB2D-4C3C8C217F7B}"/>
               </a:ext>
             </a:extLst>
           </p:cNvPr>
@@ -8505,7 +8505,7 @@
           <p:cNvPr id="24" name="">
             <a:extLst xmlns:a="http://schemas.openxmlformats.org/drawingml/2006/main">
               <a:ext uri="{FF2B5EF4-FFF2-40B4-BE49-F238E27FC236}">
-                <a16:creationId xmlns:a16="http://schemas.microsoft.com/office/drawing/2014/main" id="{40824ABF-880E-49EA-B6FE-9218A6756DFA}"/>
+                <a16:creationId xmlns:a16="http://schemas.microsoft.com/office/drawing/2014/main" id="{7F915DC2-F65B-489E-A649-F0F9907F5679}"/>
               </a:ext>
             </a:extLst>
           </p:cNvPr>
@@ -8536,7 +8536,7 @@
           <p:cNvPr id="25" name="">
             <a:extLst xmlns:a="http://schemas.openxmlformats.org/drawingml/2006/main">
               <a:ext uri="{FF2B5EF4-FFF2-40B4-BE49-F238E27FC236}">
-                <a16:creationId xmlns:a16="http://schemas.microsoft.com/office/drawing/2014/main" id="{33B27831-C5B6-44D7-8700-7AC47FE79B4A}"/>
+                <a16:creationId xmlns:a16="http://schemas.microsoft.com/office/drawing/2014/main" id="{CBEFF6B1-8E10-480D-A435-567FDC93A301}"/>
               </a:ext>
             </a:extLst>
           </p:cNvPr>
@@ -8567,7 +8567,7 @@
           <p:cNvPr id="26" name="">
             <a:extLst xmlns:a="http://schemas.openxmlformats.org/drawingml/2006/main">
               <a:ext uri="{FF2B5EF4-FFF2-40B4-BE49-F238E27FC236}">
-                <a16:creationId xmlns:a16="http://schemas.microsoft.com/office/drawing/2014/main" id="{EB1A50B1-2FCF-43A4-896B-DA2765376CC7}"/>
+                <a16:creationId xmlns:a16="http://schemas.microsoft.com/office/drawing/2014/main" id="{111E2DB0-CA0F-49B6-9B42-3159208DF268}"/>
               </a:ext>
             </a:extLst>
           </p:cNvPr>
@@ -8598,7 +8598,7 @@
           <p:cNvPr id="27" name="">
             <a:extLst xmlns:a="http://schemas.openxmlformats.org/drawingml/2006/main">
               <a:ext uri="{FF2B5EF4-FFF2-40B4-BE49-F238E27FC236}">
-                <a16:creationId xmlns:a16="http://schemas.microsoft.com/office/drawing/2014/main" id="{A0BE424A-F2CD-49AD-BDE9-E3E5F2145DC6}"/>
+                <a16:creationId xmlns:a16="http://schemas.microsoft.com/office/drawing/2014/main" id="{5B7535B0-77F4-4596-B0DE-6259270FC8A1}"/>
               </a:ext>
             </a:extLst>
           </p:cNvPr>
@@ -8629,7 +8629,7 @@
           <p:cNvPr id="28" name="">
             <a:extLst xmlns:a="http://schemas.openxmlformats.org/drawingml/2006/main">
               <a:ext uri="{FF2B5EF4-FFF2-40B4-BE49-F238E27FC236}">
-                <a16:creationId xmlns:a16="http://schemas.microsoft.com/office/drawing/2014/main" id="{624B2202-894B-4D7E-AC7B-732D320FA281}"/>
+                <a16:creationId xmlns:a16="http://schemas.microsoft.com/office/drawing/2014/main" id="{63378B9D-7031-4010-B5D1-DD444F615B40}"/>
               </a:ext>
             </a:extLst>
           </p:cNvPr>
@@ -8660,7 +8660,7 @@
           <p:cNvPr id="29" name="">
             <a:extLst xmlns:a="http://schemas.openxmlformats.org/drawingml/2006/main">
               <a:ext uri="{FF2B5EF4-FFF2-40B4-BE49-F238E27FC236}">
-                <a16:creationId xmlns:a16="http://schemas.microsoft.com/office/drawing/2014/main" id="{AFEF6CC8-F5B5-496E-AF3B-524A39680075}"/>
+                <a16:creationId xmlns:a16="http://schemas.microsoft.com/office/drawing/2014/main" id="{C7449276-B80F-4FEC-94CE-1CB7F8DEB9D1}"/>
               </a:ext>
             </a:extLst>
           </p:cNvPr>
@@ -8691,7 +8691,7 @@
           <p:cNvPr id="30" name="">
             <a:extLst xmlns:a="http://schemas.openxmlformats.org/drawingml/2006/main">
               <a:ext uri="{FF2B5EF4-FFF2-40B4-BE49-F238E27FC236}">
-                <a16:creationId xmlns:a16="http://schemas.microsoft.com/office/drawing/2014/main" id="{7BA973DE-5FBD-4729-8016-23BF839C3234}"/>
+                <a16:creationId xmlns:a16="http://schemas.microsoft.com/office/drawing/2014/main" id="{FE179E24-0EDF-4A08-BB77-C66E174F5C16}"/>
               </a:ext>
             </a:extLst>
           </p:cNvPr>
@@ -8722,7 +8722,7 @@
           <p:cNvPr id="31" name="">
             <a:extLst xmlns:a="http://schemas.openxmlformats.org/drawingml/2006/main">
               <a:ext uri="{FF2B5EF4-FFF2-40B4-BE49-F238E27FC236}">
-                <a16:creationId xmlns:a16="http://schemas.microsoft.com/office/drawing/2014/main" id="{84086171-7456-4E26-951D-C1AD6E8B8396}"/>
+                <a16:creationId xmlns:a16="http://schemas.microsoft.com/office/drawing/2014/main" id="{3B0AAE63-7FD6-43FE-9E27-09E5C1E01B20}"/>
               </a:ext>
             </a:extLst>
           </p:cNvPr>
@@ -8772,7 +8772,7 @@
           <p:cNvPr id="32" name="">
             <a:extLst xmlns:a="http://schemas.openxmlformats.org/drawingml/2006/main">
               <a:ext uri="{FF2B5EF4-FFF2-40B4-BE49-F238E27FC236}">
-                <a16:creationId xmlns:a16="http://schemas.microsoft.com/office/drawing/2014/main" id="{C210C234-6F27-4DC7-A0A5-EEC33AB3FA52}"/>
+                <a16:creationId xmlns:a16="http://schemas.microsoft.com/office/drawing/2014/main" id="{F184BF07-6CA8-4158-88E8-4EB0C524FC6A}"/>
               </a:ext>
             </a:extLst>
           </p:cNvPr>
@@ -8822,7 +8822,7 @@
           <p:cNvPr id="33" name="">
             <a:extLst xmlns:a="http://schemas.openxmlformats.org/drawingml/2006/main">
               <a:ext uri="{FF2B5EF4-FFF2-40B4-BE49-F238E27FC236}">
-                <a16:creationId xmlns:a16="http://schemas.microsoft.com/office/drawing/2014/main" id="{87F245C1-300D-4039-955F-8B83706F8C1F}"/>
+                <a16:creationId xmlns:a16="http://schemas.microsoft.com/office/drawing/2014/main" id="{A1627108-565D-4550-A953-DD782FBAFD63}"/>
               </a:ext>
             </a:extLst>
           </p:cNvPr>
@@ -8872,7 +8872,7 @@
           <p:cNvPr id="34" name="">
             <a:extLst xmlns:a="http://schemas.openxmlformats.org/drawingml/2006/main">
               <a:ext uri="{FF2B5EF4-FFF2-40B4-BE49-F238E27FC236}">
-                <a16:creationId xmlns:a16="http://schemas.microsoft.com/office/drawing/2014/main" id="{87049492-984A-4F35-96F4-CC73D704DFC3}"/>
+                <a16:creationId xmlns:a16="http://schemas.microsoft.com/office/drawing/2014/main" id="{BD1E0070-6EA0-44AB-AFB9-BC012D0BDB35}"/>
               </a:ext>
             </a:extLst>
           </p:cNvPr>
@@ -8922,7 +8922,7 @@
           <p:cNvPr id="35" name="">
             <a:extLst xmlns:a="http://schemas.openxmlformats.org/drawingml/2006/main">
               <a:ext uri="{FF2B5EF4-FFF2-40B4-BE49-F238E27FC236}">
-                <a16:creationId xmlns:a16="http://schemas.microsoft.com/office/drawing/2014/main" id="{E39C0DDE-8C57-4969-AD0B-A3C08E07F2FB}"/>
+                <a16:creationId xmlns:a16="http://schemas.microsoft.com/office/drawing/2014/main" id="{9DFAB1D3-FEB3-40E8-A528-64DF23962514}"/>
               </a:ext>
             </a:extLst>
           </p:cNvPr>
@@ -8972,7 +8972,7 @@
           <p:cNvPr id="36" name="">
             <a:extLst xmlns:a="http://schemas.openxmlformats.org/drawingml/2006/main">
               <a:ext uri="{FF2B5EF4-FFF2-40B4-BE49-F238E27FC236}">
-                <a16:creationId xmlns:a16="http://schemas.microsoft.com/office/drawing/2014/main" id="{EDE08BD7-E766-4D3F-9912-F82128AF8ED1}"/>
+                <a16:creationId xmlns:a16="http://schemas.microsoft.com/office/drawing/2014/main" id="{506D69A7-CACB-45B2-AE3F-B8835AFD5244}"/>
               </a:ext>
             </a:extLst>
           </p:cNvPr>
@@ -9022,7 +9022,7 @@
           <p:cNvPr id="37" name="">
             <a:extLst xmlns:a="http://schemas.openxmlformats.org/drawingml/2006/main">
               <a:ext uri="{FF2B5EF4-FFF2-40B4-BE49-F238E27FC236}">
-                <a16:creationId xmlns:a16="http://schemas.microsoft.com/office/drawing/2014/main" id="{3DA62E95-F2AF-408F-847C-884F26D6458B}"/>
+                <a16:creationId xmlns:a16="http://schemas.microsoft.com/office/drawing/2014/main" id="{C8668A5F-4894-414D-896E-C1AE425663F4}"/>
               </a:ext>
             </a:extLst>
           </p:cNvPr>
@@ -9072,7 +9072,7 @@
           <p:cNvPr id="38" name="">
             <a:extLst xmlns:a="http://schemas.openxmlformats.org/drawingml/2006/main">
               <a:ext uri="{FF2B5EF4-FFF2-40B4-BE49-F238E27FC236}">
-                <a16:creationId xmlns:a16="http://schemas.microsoft.com/office/drawing/2014/main" id="{BBF83F0D-3A37-4144-AE38-56D217E02629}"/>
+                <a16:creationId xmlns:a16="http://schemas.microsoft.com/office/drawing/2014/main" id="{37F6F535-AE4B-4E2E-B2C0-CA7984333119}"/>
               </a:ext>
             </a:extLst>
           </p:cNvPr>
@@ -9122,7 +9122,7 @@
           <p:cNvPr id="39" name="">
             <a:extLst xmlns:a="http://schemas.openxmlformats.org/drawingml/2006/main">
               <a:ext uri="{FF2B5EF4-FFF2-40B4-BE49-F238E27FC236}">
-                <a16:creationId xmlns:a16="http://schemas.microsoft.com/office/drawing/2014/main" id="{8B7A901C-E476-40D0-82D5-239C1640235D}"/>
+                <a16:creationId xmlns:a16="http://schemas.microsoft.com/office/drawing/2014/main" id="{798AF4F4-C338-41B2-A04D-420BFBFBC1C6}"/>
               </a:ext>
             </a:extLst>
           </p:cNvPr>
@@ -9172,7 +9172,7 @@
           <p:cNvPr id="40" name="">
             <a:extLst xmlns:a="http://schemas.openxmlformats.org/drawingml/2006/main">
               <a:ext uri="{FF2B5EF4-FFF2-40B4-BE49-F238E27FC236}">
-                <a16:creationId xmlns:a16="http://schemas.microsoft.com/office/drawing/2014/main" id="{ECC3491D-3D1D-4FC3-A03D-19DB8CD638C0}"/>
+                <a16:creationId xmlns:a16="http://schemas.microsoft.com/office/drawing/2014/main" id="{895A430B-FC59-42D0-8B04-9C91AA619342}"/>
               </a:ext>
             </a:extLst>
           </p:cNvPr>
@@ -9222,7 +9222,7 @@
           <p:cNvPr id="41" name="">
             <a:extLst xmlns:a="http://schemas.openxmlformats.org/drawingml/2006/main">
               <a:ext uri="{FF2B5EF4-FFF2-40B4-BE49-F238E27FC236}">
-                <a16:creationId xmlns:a16="http://schemas.microsoft.com/office/drawing/2014/main" id="{FDF50318-69A1-4D47-AA6C-9BC84908C08F}"/>
+                <a16:creationId xmlns:a16="http://schemas.microsoft.com/office/drawing/2014/main" id="{1C0BC8B8-6318-491C-9CB5-DE7AD7738FBE}"/>
               </a:ext>
             </a:extLst>
           </p:cNvPr>
@@ -9272,7 +9272,7 @@
           <p:cNvPr id="42" name="">
             <a:extLst xmlns:a="http://schemas.openxmlformats.org/drawingml/2006/main">
               <a:ext uri="{FF2B5EF4-FFF2-40B4-BE49-F238E27FC236}">
-                <a16:creationId xmlns:a16="http://schemas.microsoft.com/office/drawing/2014/main" id="{7CF76BA0-1767-4794-8C2C-D818F618ACCB}"/>
+                <a16:creationId xmlns:a16="http://schemas.microsoft.com/office/drawing/2014/main" id="{FCCC8104-F48F-49E8-98CA-47923BAF384E}"/>
               </a:ext>
             </a:extLst>
           </p:cNvPr>
@@ -9322,7 +9322,7 @@
           <p:cNvPr id="43" name="">
             <a:extLst xmlns:a="http://schemas.openxmlformats.org/drawingml/2006/main">
               <a:ext uri="{FF2B5EF4-FFF2-40B4-BE49-F238E27FC236}">
-                <a16:creationId xmlns:a16="http://schemas.microsoft.com/office/drawing/2014/main" id="{E3796998-76C0-48A8-991C-23E7E01B6D16}"/>
+                <a16:creationId xmlns:a16="http://schemas.microsoft.com/office/drawing/2014/main" id="{CA81770A-C963-423B-B7C3-6B560CD3CADD}"/>
               </a:ext>
             </a:extLst>
           </p:cNvPr>
@@ -9372,7 +9372,7 @@
           <p:cNvPr id="44" name="">
             <a:extLst xmlns:a="http://schemas.openxmlformats.org/drawingml/2006/main">
               <a:ext uri="{FF2B5EF4-FFF2-40B4-BE49-F238E27FC236}">
-                <a16:creationId xmlns:a16="http://schemas.microsoft.com/office/drawing/2014/main" id="{94683DD2-67A7-41B4-B165-273FA45C2AEE}"/>
+                <a16:creationId xmlns:a16="http://schemas.microsoft.com/office/drawing/2014/main" id="{E76F581E-49D0-4927-AD20-5CCD4EC5C04E}"/>
               </a:ext>
             </a:extLst>
           </p:cNvPr>
@@ -9422,7 +9422,7 @@
           <p:cNvPr id="45" name="">
             <a:extLst xmlns:a="http://schemas.openxmlformats.org/drawingml/2006/main">
               <a:ext uri="{FF2B5EF4-FFF2-40B4-BE49-F238E27FC236}">
-                <a16:creationId xmlns:a16="http://schemas.microsoft.com/office/drawing/2014/main" id="{2398B9C2-413F-4594-971E-ADB4204D0ADA}"/>
+                <a16:creationId xmlns:a16="http://schemas.microsoft.com/office/drawing/2014/main" id="{105CA1EE-E258-4450-979E-E138E3FA09F8}"/>
               </a:ext>
             </a:extLst>
           </p:cNvPr>
@@ -9472,7 +9472,7 @@
           <p:cNvPr id="46" name="">
             <a:extLst xmlns:a="http://schemas.openxmlformats.org/drawingml/2006/main">
               <a:ext uri="{FF2B5EF4-FFF2-40B4-BE49-F238E27FC236}">
-                <a16:creationId xmlns:a16="http://schemas.microsoft.com/office/drawing/2014/main" id="{800BE69C-B1FC-47EB-B7B8-23BA290BF3B3}"/>
+                <a16:creationId xmlns:a16="http://schemas.microsoft.com/office/drawing/2014/main" id="{D112BD05-56DE-4FF0-9765-B8B981B1DCAD}"/>
               </a:ext>
             </a:extLst>
           </p:cNvPr>
@@ -9522,7 +9522,7 @@
           <p:cNvPr id="47" name="">
             <a:extLst xmlns:a="http://schemas.openxmlformats.org/drawingml/2006/main">
               <a:ext uri="{FF2B5EF4-FFF2-40B4-BE49-F238E27FC236}">
-                <a16:creationId xmlns:a16="http://schemas.microsoft.com/office/drawing/2014/main" id="{B199E508-8C32-4928-BC35-89DA7E134A04}"/>
+                <a16:creationId xmlns:a16="http://schemas.microsoft.com/office/drawing/2014/main" id="{4042EBAC-E0A9-4123-8E5C-D8D5D3AF33F9}"/>
               </a:ext>
             </a:extLst>
           </p:cNvPr>
@@ -9572,7 +9572,7 @@
           <p:cNvPr id="48" name="">
             <a:extLst xmlns:a="http://schemas.openxmlformats.org/drawingml/2006/main">
               <a:ext uri="{FF2B5EF4-FFF2-40B4-BE49-F238E27FC236}">
-                <a16:creationId xmlns:a16="http://schemas.microsoft.com/office/drawing/2014/main" id="{5B97BCDF-9335-4676-92D3-C1B9A743720C}"/>
+                <a16:creationId xmlns:a16="http://schemas.microsoft.com/office/drawing/2014/main" id="{5035D265-5A89-4342-B067-CBBB71B88821}"/>
               </a:ext>
             </a:extLst>
           </p:cNvPr>
@@ -9622,7 +9622,7 @@
           <p:cNvPr id="49" name="">
             <a:extLst xmlns:a="http://schemas.openxmlformats.org/drawingml/2006/main">
               <a:ext uri="{FF2B5EF4-FFF2-40B4-BE49-F238E27FC236}">
-                <a16:creationId xmlns:a16="http://schemas.microsoft.com/office/drawing/2014/main" id="{1F0E0EBC-9961-42C3-A9D0-387ADA1B0D05}"/>
+                <a16:creationId xmlns:a16="http://schemas.microsoft.com/office/drawing/2014/main" id="{C303778C-6339-4362-BFBE-DAA22AAE2106}"/>
               </a:ext>
             </a:extLst>
           </p:cNvPr>
@@ -9672,7 +9672,7 @@
           <p:cNvPr id="50" name="">
             <a:extLst xmlns:a="http://schemas.openxmlformats.org/drawingml/2006/main">
               <a:ext uri="{FF2B5EF4-FFF2-40B4-BE49-F238E27FC236}">
-                <a16:creationId xmlns:a16="http://schemas.microsoft.com/office/drawing/2014/main" id="{35F519E6-0FD1-4A2A-BED8-16B3BEE88931}"/>
+                <a16:creationId xmlns:a16="http://schemas.microsoft.com/office/drawing/2014/main" id="{1688E8B6-0CC1-450D-8367-E020079A28B0}"/>
               </a:ext>
             </a:extLst>
           </p:cNvPr>
@@ -9722,7 +9722,7 @@
           <p:cNvPr id="51" name="">
             <a:extLst xmlns:a="http://schemas.openxmlformats.org/drawingml/2006/main">
               <a:ext uri="{FF2B5EF4-FFF2-40B4-BE49-F238E27FC236}">
-                <a16:creationId xmlns:a16="http://schemas.microsoft.com/office/drawing/2014/main" id="{51B5E739-F9B3-46FC-B822-C897CD590E8E}"/>
+                <a16:creationId xmlns:a16="http://schemas.microsoft.com/office/drawing/2014/main" id="{A270E0D3-B9FD-4A98-8524-F86C9791A647}"/>
               </a:ext>
             </a:extLst>
           </p:cNvPr>
@@ -9772,7 +9772,7 @@
           <p:cNvPr id="52" name="">
             <a:extLst xmlns:a="http://schemas.openxmlformats.org/drawingml/2006/main">
               <a:ext uri="{FF2B5EF4-FFF2-40B4-BE49-F238E27FC236}">
-                <a16:creationId xmlns:a16="http://schemas.microsoft.com/office/drawing/2014/main" id="{1CCA3A85-A966-4BB0-B75F-51CA0B9679BC}"/>
+                <a16:creationId xmlns:a16="http://schemas.microsoft.com/office/drawing/2014/main" id="{0DD063C1-8083-4146-B00E-42CBEC9F41F6}"/>
               </a:ext>
             </a:extLst>
           </p:cNvPr>
@@ -9822,7 +9822,7 @@
           <p:cNvPr id="53" name="">
             <a:extLst xmlns:a="http://schemas.openxmlformats.org/drawingml/2006/main">
               <a:ext uri="{FF2B5EF4-FFF2-40B4-BE49-F238E27FC236}">
-                <a16:creationId xmlns:a16="http://schemas.microsoft.com/office/drawing/2014/main" id="{5C7DFE27-38D3-46EA-A122-EC575E836C7C}"/>
+                <a16:creationId xmlns:a16="http://schemas.microsoft.com/office/drawing/2014/main" id="{F3655D08-C41C-4985-A0E5-CD441437FF18}"/>
               </a:ext>
             </a:extLst>
           </p:cNvPr>
@@ -9872,7 +9872,7 @@
           <p:cNvPr id="54" name="">
             <a:extLst xmlns:a="http://schemas.openxmlformats.org/drawingml/2006/main">
               <a:ext uri="{FF2B5EF4-FFF2-40B4-BE49-F238E27FC236}">
-                <a16:creationId xmlns:a16="http://schemas.microsoft.com/office/drawing/2014/main" id="{CA39BEBA-F884-41A3-89B3-F41E647359A3}"/>
+                <a16:creationId xmlns:a16="http://schemas.microsoft.com/office/drawing/2014/main" id="{019F542C-BFDB-4E59-9F21-FB571F89AB56}"/>
               </a:ext>
             </a:extLst>
           </p:cNvPr>
@@ -9920,7 +9920,7 @@
     </p:spTree>
     <p:extLst>
       <p:ext uri="{BB962C8B-B14F-4D97-AF65-F5344CB8AC3E}">
-        <p14:creationId xmlns:p14="http://schemas.microsoft.com/office/powerpoint/2010/main" val="1297938761"/>
+        <p14:creationId xmlns:p14="http://schemas.microsoft.com/office/powerpoint/2010/main" val="103656983"/>
       </p:ext>
     </p:extLst>
   </p:cSld>
@@ -9951,7 +9951,7 @@
           <p:cNvPr id="38" name="slide-7-title">
             <a:extLst xmlns:a="http://schemas.openxmlformats.org/drawingml/2006/main">
               <a:ext uri="{FF2B5EF4-FFF2-40B4-BE49-F238E27FC236}">
-                <a16:creationId xmlns:a16="http://schemas.microsoft.com/office/drawing/2014/main" id="{F0B1E1F5-A5C2-4D0E-A90F-ABBFADE2F5E2}"/>
+                <a16:creationId xmlns:a16="http://schemas.microsoft.com/office/drawing/2014/main" id="{5A11881D-9CC9-45A1-8367-2F9EB13C2576}"/>
               </a:ext>
             </a:extLst>
           </p:cNvPr>
@@ -10001,7 +10001,7 @@
           <p:cNvPr id="2" name="slide-7-subtitle">
             <a:extLst xmlns:a="http://schemas.openxmlformats.org/drawingml/2006/main">
               <a:ext uri="{FF2B5EF4-FFF2-40B4-BE49-F238E27FC236}">
-                <a16:creationId xmlns:a16="http://schemas.microsoft.com/office/drawing/2014/main" id="{1493642A-B057-4845-91C5-FCD2F365EF42}"/>
+                <a16:creationId xmlns:a16="http://schemas.microsoft.com/office/drawing/2014/main" id="{C914B231-FE88-4481-95B6-C54609623C5F}"/>
               </a:ext>
             </a:extLst>
           </p:cNvPr>
@@ -10051,7 +10051,7 @@
           <p:cNvPr id="3" name="slide-7-footer">
             <a:extLst xmlns:a="http://schemas.openxmlformats.org/drawingml/2006/main">
               <a:ext uri="{FF2B5EF4-FFF2-40B4-BE49-F238E27FC236}">
-                <a16:creationId xmlns:a16="http://schemas.microsoft.com/office/drawing/2014/main" id="{4B009002-6978-41DF-9175-511454B91CEC}"/>
+                <a16:creationId xmlns:a16="http://schemas.microsoft.com/office/drawing/2014/main" id="{76A23A5B-F797-4069-A2F8-A9F10CCD3545}"/>
               </a:ext>
             </a:extLst>
           </p:cNvPr>
@@ -10101,7 +10101,7 @@
           <p:cNvPr id="4" name="">
             <a:extLst xmlns:a="http://schemas.openxmlformats.org/drawingml/2006/main">
               <a:ext uri="{FF2B5EF4-FFF2-40B4-BE49-F238E27FC236}">
-                <a16:creationId xmlns:a16="http://schemas.microsoft.com/office/drawing/2014/main" id="{90F2717F-8F05-42E2-80D3-E59AB7B821AD}"/>
+                <a16:creationId xmlns:a16="http://schemas.microsoft.com/office/drawing/2014/main" id="{DB6F485C-8257-41BA-9B19-4F11C3945D70}"/>
               </a:ext>
             </a:extLst>
           </p:cNvPr>
@@ -10134,7 +10134,7 @@
           <p:cNvPr id="5" name="">
             <a:extLst xmlns:a="http://schemas.openxmlformats.org/drawingml/2006/main">
               <a:ext uri="{FF2B5EF4-FFF2-40B4-BE49-F238E27FC236}">
-                <a16:creationId xmlns:a16="http://schemas.microsoft.com/office/drawing/2014/main" id="{078C8E11-BE42-4AC2-863E-B79E2D295D4F}"/>
+                <a16:creationId xmlns:a16="http://schemas.microsoft.com/office/drawing/2014/main" id="{F383BF74-3764-49A4-84BF-C3C9FE259386}"/>
               </a:ext>
             </a:extLst>
           </p:cNvPr>
@@ -10165,7 +10165,7 @@
           <p:cNvPr id="6" name="">
             <a:extLst xmlns:a="http://schemas.openxmlformats.org/drawingml/2006/main">
               <a:ext uri="{FF2B5EF4-FFF2-40B4-BE49-F238E27FC236}">
-                <a16:creationId xmlns:a16="http://schemas.microsoft.com/office/drawing/2014/main" id="{9CC83A8D-E48D-4B94-B7EF-EA50E0DF3540}"/>
+                <a16:creationId xmlns:a16="http://schemas.microsoft.com/office/drawing/2014/main" id="{941CDB1B-4274-4C43-A887-0E40EFA95D77}"/>
               </a:ext>
             </a:extLst>
           </p:cNvPr>
@@ -10196,7 +10196,7 @@
           <p:cNvPr id="7" name="">
             <a:extLst xmlns:a="http://schemas.openxmlformats.org/drawingml/2006/main">
               <a:ext uri="{FF2B5EF4-FFF2-40B4-BE49-F238E27FC236}">
-                <a16:creationId xmlns:a16="http://schemas.microsoft.com/office/drawing/2014/main" id="{B46DC3FA-4AC5-45F7-A15E-9BCFDBAC6DA4}"/>
+                <a16:creationId xmlns:a16="http://schemas.microsoft.com/office/drawing/2014/main" id="{05B67FE3-6997-487F-B45A-69587959BBFF}"/>
               </a:ext>
             </a:extLst>
           </p:cNvPr>
@@ -10227,7 +10227,7 @@
           <p:cNvPr id="8" name="">
             <a:extLst xmlns:a="http://schemas.openxmlformats.org/drawingml/2006/main">
               <a:ext uri="{FF2B5EF4-FFF2-40B4-BE49-F238E27FC236}">
-                <a16:creationId xmlns:a16="http://schemas.microsoft.com/office/drawing/2014/main" id="{E53AF648-56CB-4ED7-83EB-9362056B0723}"/>
+                <a16:creationId xmlns:a16="http://schemas.microsoft.com/office/drawing/2014/main" id="{87401384-F181-4079-832E-A737E033EE07}"/>
               </a:ext>
             </a:extLst>
           </p:cNvPr>
@@ -10258,7 +10258,7 @@
           <p:cNvPr id="9" name="">
             <a:extLst xmlns:a="http://schemas.openxmlformats.org/drawingml/2006/main">
               <a:ext uri="{FF2B5EF4-FFF2-40B4-BE49-F238E27FC236}">
-                <a16:creationId xmlns:a16="http://schemas.microsoft.com/office/drawing/2014/main" id="{06AAD4B4-3A32-4983-B526-326482DC5E78}"/>
+                <a16:creationId xmlns:a16="http://schemas.microsoft.com/office/drawing/2014/main" id="{AC1D7629-61A6-4083-87E9-3E3FBF05BB1E}"/>
               </a:ext>
             </a:extLst>
           </p:cNvPr>
@@ -10289,7 +10289,7 @@
           <p:cNvPr id="10" name="">
             <a:extLst xmlns:a="http://schemas.openxmlformats.org/drawingml/2006/main">
               <a:ext uri="{FF2B5EF4-FFF2-40B4-BE49-F238E27FC236}">
-                <a16:creationId xmlns:a16="http://schemas.microsoft.com/office/drawing/2014/main" id="{CA3EA160-3CF3-4356-A453-AF3C7B5069F2}"/>
+                <a16:creationId xmlns:a16="http://schemas.microsoft.com/office/drawing/2014/main" id="{43A7E194-7660-4E8B-939B-E3F86FC3D223}"/>
               </a:ext>
             </a:extLst>
           </p:cNvPr>
@@ -10320,7 +10320,7 @@
           <p:cNvPr id="11" name="">
             <a:extLst xmlns:a="http://schemas.openxmlformats.org/drawingml/2006/main">
               <a:ext uri="{FF2B5EF4-FFF2-40B4-BE49-F238E27FC236}">
-                <a16:creationId xmlns:a16="http://schemas.microsoft.com/office/drawing/2014/main" id="{A902AD43-D1EF-41E0-BDCD-6F9BC32F1F6F}"/>
+                <a16:creationId xmlns:a16="http://schemas.microsoft.com/office/drawing/2014/main" id="{DAD70CE0-FB38-4DB7-8425-1FFD30A4EC1D}"/>
               </a:ext>
             </a:extLst>
           </p:cNvPr>
@@ -10351,7 +10351,7 @@
           <p:cNvPr id="12" name="">
             <a:extLst xmlns:a="http://schemas.openxmlformats.org/drawingml/2006/main">
               <a:ext uri="{FF2B5EF4-FFF2-40B4-BE49-F238E27FC236}">
-                <a16:creationId xmlns:a16="http://schemas.microsoft.com/office/drawing/2014/main" id="{72865638-DC19-4AD6-9173-BED5B39C30A6}"/>
+                <a16:creationId xmlns:a16="http://schemas.microsoft.com/office/drawing/2014/main" id="{CFF117DC-D644-42C8-86C2-557E5D5E1365}"/>
               </a:ext>
             </a:extLst>
           </p:cNvPr>
@@ -10382,7 +10382,7 @@
           <p:cNvPr id="13" name="">
             <a:extLst xmlns:a="http://schemas.openxmlformats.org/drawingml/2006/main">
               <a:ext uri="{FF2B5EF4-FFF2-40B4-BE49-F238E27FC236}">
-                <a16:creationId xmlns:a16="http://schemas.microsoft.com/office/drawing/2014/main" id="{D63248C1-3116-4EFB-B3D1-939C54192564}"/>
+                <a16:creationId xmlns:a16="http://schemas.microsoft.com/office/drawing/2014/main" id="{6B53AE5C-A342-486C-84AA-F916E83473CF}"/>
               </a:ext>
             </a:extLst>
           </p:cNvPr>
@@ -10413,7 +10413,7 @@
           <p:cNvPr id="14" name="">
             <a:extLst xmlns:a="http://schemas.openxmlformats.org/drawingml/2006/main">
               <a:ext uri="{FF2B5EF4-FFF2-40B4-BE49-F238E27FC236}">
-                <a16:creationId xmlns:a16="http://schemas.microsoft.com/office/drawing/2014/main" id="{3A48AB7F-3FD4-4FDA-9F64-1479A89B1693}"/>
+                <a16:creationId xmlns:a16="http://schemas.microsoft.com/office/drawing/2014/main" id="{8EF6B565-665B-439A-936F-4FBA251DB3B9}"/>
               </a:ext>
             </a:extLst>
           </p:cNvPr>
@@ -10444,7 +10444,7 @@
           <p:cNvPr id="15" name="">
             <a:extLst xmlns:a="http://schemas.openxmlformats.org/drawingml/2006/main">
               <a:ext uri="{FF2B5EF4-FFF2-40B4-BE49-F238E27FC236}">
-                <a16:creationId xmlns:a16="http://schemas.microsoft.com/office/drawing/2014/main" id="{14B1A039-5448-4A49-B384-D1041EFE3D2C}"/>
+                <a16:creationId xmlns:a16="http://schemas.microsoft.com/office/drawing/2014/main" id="{95914D67-E6A6-4C6E-B8C8-4576F1E15417}"/>
               </a:ext>
             </a:extLst>
           </p:cNvPr>
@@ -10475,7 +10475,7 @@
           <p:cNvPr id="16" name="">
             <a:extLst xmlns:a="http://schemas.openxmlformats.org/drawingml/2006/main">
               <a:ext uri="{FF2B5EF4-FFF2-40B4-BE49-F238E27FC236}">
-                <a16:creationId xmlns:a16="http://schemas.microsoft.com/office/drawing/2014/main" id="{D8E74B9B-0C1B-4C99-8A80-8ED40B034E7E}"/>
+                <a16:creationId xmlns:a16="http://schemas.microsoft.com/office/drawing/2014/main" id="{7249E98E-7E60-4B23-ABD2-2B92ED1DF5CD}"/>
               </a:ext>
             </a:extLst>
           </p:cNvPr>
@@ -10525,7 +10525,7 @@
           <p:cNvPr id="17" name="">
             <a:extLst xmlns:a="http://schemas.openxmlformats.org/drawingml/2006/main">
               <a:ext uri="{FF2B5EF4-FFF2-40B4-BE49-F238E27FC236}">
-                <a16:creationId xmlns:a16="http://schemas.microsoft.com/office/drawing/2014/main" id="{415DA1F9-C60D-4D52-A271-E1E8F2B35AE3}"/>
+                <a16:creationId xmlns:a16="http://schemas.microsoft.com/office/drawing/2014/main" id="{E839DEF9-EE16-4791-B2D7-5A9A61A6A37E}"/>
               </a:ext>
             </a:extLst>
           </p:cNvPr>
@@ -10575,7 +10575,7 @@
           <p:cNvPr id="18" name="">
             <a:extLst xmlns:a="http://schemas.openxmlformats.org/drawingml/2006/main">
               <a:ext uri="{FF2B5EF4-FFF2-40B4-BE49-F238E27FC236}">
-                <a16:creationId xmlns:a16="http://schemas.microsoft.com/office/drawing/2014/main" id="{7D20324C-F970-4B31-A198-9D0E1C3FA0DF}"/>
+                <a16:creationId xmlns:a16="http://schemas.microsoft.com/office/drawing/2014/main" id="{55DB002B-C822-44AD-8B71-74B640664226}"/>
               </a:ext>
             </a:extLst>
           </p:cNvPr>
@@ -10625,7 +10625,7 @@
           <p:cNvPr id="19" name="">
             <a:extLst xmlns:a="http://schemas.openxmlformats.org/drawingml/2006/main">
               <a:ext uri="{FF2B5EF4-FFF2-40B4-BE49-F238E27FC236}">
-                <a16:creationId xmlns:a16="http://schemas.microsoft.com/office/drawing/2014/main" id="{408B124B-5738-4567-8599-791568753772}"/>
+                <a16:creationId xmlns:a16="http://schemas.microsoft.com/office/drawing/2014/main" id="{597078E4-682A-4805-BC2D-29ED6A6CED89}"/>
               </a:ext>
             </a:extLst>
           </p:cNvPr>
@@ -10675,7 +10675,7 @@
           <p:cNvPr id="20" name="">
             <a:extLst xmlns:a="http://schemas.openxmlformats.org/drawingml/2006/main">
               <a:ext uri="{FF2B5EF4-FFF2-40B4-BE49-F238E27FC236}">
-                <a16:creationId xmlns:a16="http://schemas.microsoft.com/office/drawing/2014/main" id="{52B5DE66-2E6C-430B-8C51-FA351EA45DC2}"/>
+                <a16:creationId xmlns:a16="http://schemas.microsoft.com/office/drawing/2014/main" id="{959B410F-315F-41EE-A697-C47A5F4B78A9}"/>
               </a:ext>
             </a:extLst>
           </p:cNvPr>
@@ -10725,7 +10725,7 @@
           <p:cNvPr id="21" name="">
             <a:extLst xmlns:a="http://schemas.openxmlformats.org/drawingml/2006/main">
               <a:ext uri="{FF2B5EF4-FFF2-40B4-BE49-F238E27FC236}">
-                <a16:creationId xmlns:a16="http://schemas.microsoft.com/office/drawing/2014/main" id="{7866DE53-1106-403D-9FAF-BDFA8039A150}"/>
+                <a16:creationId xmlns:a16="http://schemas.microsoft.com/office/drawing/2014/main" id="{00A122CE-7350-4D7F-A80A-F84336A5EF63}"/>
               </a:ext>
             </a:extLst>
           </p:cNvPr>
@@ -10775,7 +10775,7 @@
           <p:cNvPr id="22" name="">
             <a:extLst xmlns:a="http://schemas.openxmlformats.org/drawingml/2006/main">
               <a:ext uri="{FF2B5EF4-FFF2-40B4-BE49-F238E27FC236}">
-                <a16:creationId xmlns:a16="http://schemas.microsoft.com/office/drawing/2014/main" id="{A71AC37C-F17C-40E7-BB84-9A90BAFE52A3}"/>
+                <a16:creationId xmlns:a16="http://schemas.microsoft.com/office/drawing/2014/main" id="{63E312C1-645F-4A6C-9A2B-9FEAEB181554}"/>
               </a:ext>
             </a:extLst>
           </p:cNvPr>
@@ -10825,7 +10825,7 @@
           <p:cNvPr id="23" name="">
             <a:extLst xmlns:a="http://schemas.openxmlformats.org/drawingml/2006/main">
               <a:ext uri="{FF2B5EF4-FFF2-40B4-BE49-F238E27FC236}">
-                <a16:creationId xmlns:a16="http://schemas.microsoft.com/office/drawing/2014/main" id="{0CDFA678-7C23-4422-B24F-ADD58C1E808D}"/>
+                <a16:creationId xmlns:a16="http://schemas.microsoft.com/office/drawing/2014/main" id="{C40B0E0A-98F6-47D4-B49C-40B589A09008}"/>
               </a:ext>
             </a:extLst>
           </p:cNvPr>
@@ -10875,7 +10875,7 @@
           <p:cNvPr id="24" name="">
             <a:extLst xmlns:a="http://schemas.openxmlformats.org/drawingml/2006/main">
               <a:ext uri="{FF2B5EF4-FFF2-40B4-BE49-F238E27FC236}">
-                <a16:creationId xmlns:a16="http://schemas.microsoft.com/office/drawing/2014/main" id="{AA4F9FCB-3FC5-47BE-B12E-2CF05F6E8CED}"/>
+                <a16:creationId xmlns:a16="http://schemas.microsoft.com/office/drawing/2014/main" id="{BBAE35DB-D2B2-4418-BDA8-1F367B29EF6D}"/>
               </a:ext>
             </a:extLst>
           </p:cNvPr>
@@ -10925,7 +10925,7 @@
           <p:cNvPr id="25" name="">
             <a:extLst xmlns:a="http://schemas.openxmlformats.org/drawingml/2006/main">
               <a:ext uri="{FF2B5EF4-FFF2-40B4-BE49-F238E27FC236}">
-                <a16:creationId xmlns:a16="http://schemas.microsoft.com/office/drawing/2014/main" id="{A0F165BD-D671-489D-A7BC-65282C76F28A}"/>
+                <a16:creationId xmlns:a16="http://schemas.microsoft.com/office/drawing/2014/main" id="{0407AC3C-8450-412D-8BE4-929CB98F9341}"/>
               </a:ext>
             </a:extLst>
           </p:cNvPr>
@@ -10975,7 +10975,7 @@
           <p:cNvPr id="26" name="">
             <a:extLst xmlns:a="http://schemas.openxmlformats.org/drawingml/2006/main">
               <a:ext uri="{FF2B5EF4-FFF2-40B4-BE49-F238E27FC236}">
-                <a16:creationId xmlns:a16="http://schemas.microsoft.com/office/drawing/2014/main" id="{3CED4E05-A651-48DC-B77B-57B72BA9419E}"/>
+                <a16:creationId xmlns:a16="http://schemas.microsoft.com/office/drawing/2014/main" id="{E2BDC764-25FE-44B2-854B-0FCE0C3B44C5}"/>
               </a:ext>
             </a:extLst>
           </p:cNvPr>
@@ -11025,7 +11025,7 @@
           <p:cNvPr id="27" name="">
             <a:extLst xmlns:a="http://schemas.openxmlformats.org/drawingml/2006/main">
               <a:ext uri="{FF2B5EF4-FFF2-40B4-BE49-F238E27FC236}">
-                <a16:creationId xmlns:a16="http://schemas.microsoft.com/office/drawing/2014/main" id="{7A850A45-2287-4FBA-B881-7813D961C245}"/>
+                <a16:creationId xmlns:a16="http://schemas.microsoft.com/office/drawing/2014/main" id="{32D81C49-9422-409D-B99B-5F8F3310A8B2}"/>
               </a:ext>
             </a:extLst>
           </p:cNvPr>
@@ -11075,7 +11075,7 @@
           <p:cNvPr id="28" name="">
             <a:extLst xmlns:a="http://schemas.openxmlformats.org/drawingml/2006/main">
               <a:ext uri="{FF2B5EF4-FFF2-40B4-BE49-F238E27FC236}">
-                <a16:creationId xmlns:a16="http://schemas.microsoft.com/office/drawing/2014/main" id="{1CE9D044-B88D-4D22-8489-DD2097F9877E}"/>
+                <a16:creationId xmlns:a16="http://schemas.microsoft.com/office/drawing/2014/main" id="{2C8758E3-71C0-48E0-BB72-16F1A5531567}"/>
               </a:ext>
             </a:extLst>
           </p:cNvPr>
@@ -11125,7 +11125,7 @@
           <p:cNvPr id="29" name="">
             <a:extLst xmlns:a="http://schemas.openxmlformats.org/drawingml/2006/main">
               <a:ext uri="{FF2B5EF4-FFF2-40B4-BE49-F238E27FC236}">
-                <a16:creationId xmlns:a16="http://schemas.microsoft.com/office/drawing/2014/main" id="{F0D61F45-9A9F-4D49-8D3A-F0C0E09CB859}"/>
+                <a16:creationId xmlns:a16="http://schemas.microsoft.com/office/drawing/2014/main" id="{EC7CA7F2-6642-4B1D-A83E-E8921F22C671}"/>
               </a:ext>
             </a:extLst>
           </p:cNvPr>
@@ -11175,7 +11175,7 @@
           <p:cNvPr id="30" name="">
             <a:extLst xmlns:a="http://schemas.openxmlformats.org/drawingml/2006/main">
               <a:ext uri="{FF2B5EF4-FFF2-40B4-BE49-F238E27FC236}">
-                <a16:creationId xmlns:a16="http://schemas.microsoft.com/office/drawing/2014/main" id="{3FA25C40-E784-467F-89F3-47C1FFB5A219}"/>
+                <a16:creationId xmlns:a16="http://schemas.microsoft.com/office/drawing/2014/main" id="{E488CD59-C3BE-4072-8845-B897E119D877}"/>
               </a:ext>
             </a:extLst>
           </p:cNvPr>
@@ -11225,7 +11225,7 @@
           <p:cNvPr id="31" name="">
             <a:extLst xmlns:a="http://schemas.openxmlformats.org/drawingml/2006/main">
               <a:ext uri="{FF2B5EF4-FFF2-40B4-BE49-F238E27FC236}">
-                <a16:creationId xmlns:a16="http://schemas.microsoft.com/office/drawing/2014/main" id="{4AC42376-C7F8-4B9E-8EB2-6E7389018B80}"/>
+                <a16:creationId xmlns:a16="http://schemas.microsoft.com/office/drawing/2014/main" id="{5C29B399-C938-40C5-BDC4-DDE55FCA5EE8}"/>
               </a:ext>
             </a:extLst>
           </p:cNvPr>
@@ -11275,7 +11275,7 @@
           <p:cNvPr id="32" name="">
             <a:extLst xmlns:a="http://schemas.openxmlformats.org/drawingml/2006/main">
               <a:ext uri="{FF2B5EF4-FFF2-40B4-BE49-F238E27FC236}">
-                <a16:creationId xmlns:a16="http://schemas.microsoft.com/office/drawing/2014/main" id="{0F32C8E1-69B7-4421-A5CE-043322A6DFB5}"/>
+                <a16:creationId xmlns:a16="http://schemas.microsoft.com/office/drawing/2014/main" id="{A7A61232-5B43-44D3-B627-D31D2481B9FC}"/>
               </a:ext>
             </a:extLst>
           </p:cNvPr>
@@ -11325,7 +11325,7 @@
           <p:cNvPr id="33" name="">
             <a:extLst xmlns:a="http://schemas.openxmlformats.org/drawingml/2006/main">
               <a:ext uri="{FF2B5EF4-FFF2-40B4-BE49-F238E27FC236}">
-                <a16:creationId xmlns:a16="http://schemas.microsoft.com/office/drawing/2014/main" id="{CBD11290-8263-4C19-BBF1-FACA96295AB5}"/>
+                <a16:creationId xmlns:a16="http://schemas.microsoft.com/office/drawing/2014/main" id="{1966F33E-9140-4312-8287-0669923A2E05}"/>
               </a:ext>
             </a:extLst>
           </p:cNvPr>
@@ -11375,7 +11375,7 @@
           <p:cNvPr id="34" name="">
             <a:extLst xmlns:a="http://schemas.openxmlformats.org/drawingml/2006/main">
               <a:ext uri="{FF2B5EF4-FFF2-40B4-BE49-F238E27FC236}">
-                <a16:creationId xmlns:a16="http://schemas.microsoft.com/office/drawing/2014/main" id="{AA6BD5D3-2EE1-4DF7-A947-5E6FEC2D3C3A}"/>
+                <a16:creationId xmlns:a16="http://schemas.microsoft.com/office/drawing/2014/main" id="{DC3C97FD-2605-4B82-A64D-7704D5320D32}"/>
               </a:ext>
             </a:extLst>
           </p:cNvPr>
@@ -11425,7 +11425,7 @@
           <p:cNvPr id="35" name="">
             <a:extLst xmlns:a="http://schemas.openxmlformats.org/drawingml/2006/main">
               <a:ext uri="{FF2B5EF4-FFF2-40B4-BE49-F238E27FC236}">
-                <a16:creationId xmlns:a16="http://schemas.microsoft.com/office/drawing/2014/main" id="{BCBA4115-0CC2-4CF4-80AD-918DD24E5665}"/>
+                <a16:creationId xmlns:a16="http://schemas.microsoft.com/office/drawing/2014/main" id="{76BE63B5-72D8-41B5-BBA4-9AA993A70DCD}"/>
               </a:ext>
             </a:extLst>
           </p:cNvPr>
@@ -11475,7 +11475,7 @@
           <p:cNvPr id="36" name="">
             <a:extLst xmlns:a="http://schemas.openxmlformats.org/drawingml/2006/main">
               <a:ext uri="{FF2B5EF4-FFF2-40B4-BE49-F238E27FC236}">
-                <a16:creationId xmlns:a16="http://schemas.microsoft.com/office/drawing/2014/main" id="{A0F261DA-1AA0-4588-A617-7D9A8F3D0A5A}"/>
+                <a16:creationId xmlns:a16="http://schemas.microsoft.com/office/drawing/2014/main" id="{6E23C38B-A3F8-4F22-88A4-615381C76244}"/>
               </a:ext>
             </a:extLst>
           </p:cNvPr>
@@ -11508,7 +11508,7 @@
           <p:cNvPr id="37" name="">
             <a:extLst xmlns:a="http://schemas.openxmlformats.org/drawingml/2006/main">
               <a:ext uri="{FF2B5EF4-FFF2-40B4-BE49-F238E27FC236}">
-                <a16:creationId xmlns:a16="http://schemas.microsoft.com/office/drawing/2014/main" id="{241EE7BA-7202-4A46-96C9-F60EB52948C0}"/>
+                <a16:creationId xmlns:a16="http://schemas.microsoft.com/office/drawing/2014/main" id="{896BFC4A-4BF4-4303-89B9-9872BCB8D55E}"/>
               </a:ext>
             </a:extLst>
           </p:cNvPr>
@@ -11556,7 +11556,7 @@
     </p:spTree>
     <p:extLst>
       <p:ext uri="{BB962C8B-B14F-4D97-AF65-F5344CB8AC3E}">
-        <p14:creationId xmlns:p14="http://schemas.microsoft.com/office/powerpoint/2010/main" val="441061228"/>
+        <p14:creationId xmlns:p14="http://schemas.microsoft.com/office/powerpoint/2010/main" val="216675268"/>
       </p:ext>
     </p:extLst>
   </p:cSld>
@@ -11587,7 +11587,7 @@
           <p:cNvPr id="25" name="slide-8-title">
             <a:extLst xmlns:a="http://schemas.openxmlformats.org/drawingml/2006/main">
               <a:ext uri="{FF2B5EF4-FFF2-40B4-BE49-F238E27FC236}">
-                <a16:creationId xmlns:a16="http://schemas.microsoft.com/office/drawing/2014/main" id="{48CFE401-F005-48A8-99B1-D53B9D97FC32}"/>
+                <a16:creationId xmlns:a16="http://schemas.microsoft.com/office/drawing/2014/main" id="{C3A3156A-E964-4761-A8DC-593E121C70F0}"/>
               </a:ext>
             </a:extLst>
           </p:cNvPr>
@@ -11637,7 +11637,7 @@
           <p:cNvPr id="2" name="slide-8-subtitle">
             <a:extLst xmlns:a="http://schemas.openxmlformats.org/drawingml/2006/main">
               <a:ext uri="{FF2B5EF4-FFF2-40B4-BE49-F238E27FC236}">
-                <a16:creationId xmlns:a16="http://schemas.microsoft.com/office/drawing/2014/main" id="{FDDACC0E-DD57-40E0-9719-EF51C8000E07}"/>
+                <a16:creationId xmlns:a16="http://schemas.microsoft.com/office/drawing/2014/main" id="{F82D6AFF-EECA-4F84-9025-6D1899C04E85}"/>
               </a:ext>
             </a:extLst>
           </p:cNvPr>
@@ -11687,7 +11687,7 @@
           <p:cNvPr id="3" name="slide-8-footer">
             <a:extLst xmlns:a="http://schemas.openxmlformats.org/drawingml/2006/main">
               <a:ext uri="{FF2B5EF4-FFF2-40B4-BE49-F238E27FC236}">
-                <a16:creationId xmlns:a16="http://schemas.microsoft.com/office/drawing/2014/main" id="{AE5583A9-4F6A-4845-8ED9-7B626AB51E64}"/>
+                <a16:creationId xmlns:a16="http://schemas.microsoft.com/office/drawing/2014/main" id="{660D6FFF-1C8A-44C8-BC6D-01D25453D16C}"/>
               </a:ext>
             </a:extLst>
           </p:cNvPr>
@@ -11737,7 +11737,7 @@
           <p:cNvPr id="4" name="">
             <a:extLst xmlns:a="http://schemas.openxmlformats.org/drawingml/2006/main">
               <a:ext uri="{FF2B5EF4-FFF2-40B4-BE49-F238E27FC236}">
-                <a16:creationId xmlns:a16="http://schemas.microsoft.com/office/drawing/2014/main" id="{8581FAD2-3B92-4737-B48F-FFB9DCA147AF}"/>
+                <a16:creationId xmlns:a16="http://schemas.microsoft.com/office/drawing/2014/main" id="{192CD193-53E0-4572-8821-DF6ED5B08DC9}"/>
               </a:ext>
             </a:extLst>
           </p:cNvPr>
@@ -11768,7 +11768,7 @@
           <p:cNvPr id="5" name="">
             <a:extLst xmlns:a="http://schemas.openxmlformats.org/drawingml/2006/main">
               <a:ext uri="{FF2B5EF4-FFF2-40B4-BE49-F238E27FC236}">
-                <a16:creationId xmlns:a16="http://schemas.microsoft.com/office/drawing/2014/main" id="{39B4F3A0-5396-4CB4-BD88-910536A4AF4D}"/>
+                <a16:creationId xmlns:a16="http://schemas.microsoft.com/office/drawing/2014/main" id="{4DB691F2-BABE-4EDB-A381-3C308A3A968C}"/>
               </a:ext>
             </a:extLst>
           </p:cNvPr>
@@ -11818,7 +11818,7 @@
           <p:cNvPr id="6" name="">
             <a:extLst xmlns:a="http://schemas.openxmlformats.org/drawingml/2006/main">
               <a:ext uri="{FF2B5EF4-FFF2-40B4-BE49-F238E27FC236}">
-                <a16:creationId xmlns:a16="http://schemas.microsoft.com/office/drawing/2014/main" id="{4AF109EC-9DA2-41F7-A3A4-6C5483909E0F}"/>
+                <a16:creationId xmlns:a16="http://schemas.microsoft.com/office/drawing/2014/main" id="{690C26EE-59EB-4BA1-B713-147D9D6A024B}"/>
               </a:ext>
             </a:extLst>
           </p:cNvPr>
@@ -11849,7 +11849,7 @@
           <p:cNvPr id="7" name="">
             <a:extLst xmlns:a="http://schemas.openxmlformats.org/drawingml/2006/main">
               <a:ext uri="{FF2B5EF4-FFF2-40B4-BE49-F238E27FC236}">
-                <a16:creationId xmlns:a16="http://schemas.microsoft.com/office/drawing/2014/main" id="{3A95C748-46F1-4625-B9D5-F3F0C533B471}"/>
+                <a16:creationId xmlns:a16="http://schemas.microsoft.com/office/drawing/2014/main" id="{EA6BC239-F3D3-4A27-8F84-544C9034C1D4}"/>
               </a:ext>
             </a:extLst>
           </p:cNvPr>
@@ -11899,7 +11899,7 @@
           <p:cNvPr id="8" name="">
             <a:extLst xmlns:a="http://schemas.openxmlformats.org/drawingml/2006/main">
               <a:ext uri="{FF2B5EF4-FFF2-40B4-BE49-F238E27FC236}">
-                <a16:creationId xmlns:a16="http://schemas.microsoft.com/office/drawing/2014/main" id="{8C89FDE9-1612-40EC-8F76-F28E13867FD5}"/>
+                <a16:creationId xmlns:a16="http://schemas.microsoft.com/office/drawing/2014/main" id="{7E1D37F7-92CF-4E95-AE3C-2E9D1434B818}"/>
               </a:ext>
             </a:extLst>
           </p:cNvPr>
@@ -11930,7 +11930,7 @@
           <p:cNvPr id="9" name="">
             <a:extLst xmlns:a="http://schemas.openxmlformats.org/drawingml/2006/main">
               <a:ext uri="{FF2B5EF4-FFF2-40B4-BE49-F238E27FC236}">
-                <a16:creationId xmlns:a16="http://schemas.microsoft.com/office/drawing/2014/main" id="{0B1B0B00-8102-4F80-BC15-0C190AE9F5A5}"/>
+                <a16:creationId xmlns:a16="http://schemas.microsoft.com/office/drawing/2014/main" id="{A6379F47-F7FA-41E8-BFCC-8398C335D45C}"/>
               </a:ext>
             </a:extLst>
           </p:cNvPr>
@@ -11980,7 +11980,7 @@
           <p:cNvPr id="10" name="">
             <a:extLst xmlns:a="http://schemas.openxmlformats.org/drawingml/2006/main">
               <a:ext uri="{FF2B5EF4-FFF2-40B4-BE49-F238E27FC236}">
-                <a16:creationId xmlns:a16="http://schemas.microsoft.com/office/drawing/2014/main" id="{493706B6-B34B-49BE-B570-42206C4DC63B}"/>
+                <a16:creationId xmlns:a16="http://schemas.microsoft.com/office/drawing/2014/main" id="{415B87C4-B7CC-47E5-82D7-46843339ABC5}"/>
               </a:ext>
             </a:extLst>
           </p:cNvPr>
@@ -12011,7 +12011,7 @@
           <p:cNvPr id="11" name="">
             <a:extLst xmlns:a="http://schemas.openxmlformats.org/drawingml/2006/main">
               <a:ext uri="{FF2B5EF4-FFF2-40B4-BE49-F238E27FC236}">
-                <a16:creationId xmlns:a16="http://schemas.microsoft.com/office/drawing/2014/main" id="{275C9036-3687-4DAE-A1A6-ABA6E981D0A8}"/>
+                <a16:creationId xmlns:a16="http://schemas.microsoft.com/office/drawing/2014/main" id="{441FC437-62B5-4787-97CE-9ADBBCD132E1}"/>
               </a:ext>
             </a:extLst>
           </p:cNvPr>
@@ -12061,7 +12061,7 @@
           <p:cNvPr id="12" name="">
             <a:extLst xmlns:a="http://schemas.openxmlformats.org/drawingml/2006/main">
               <a:ext uri="{FF2B5EF4-FFF2-40B4-BE49-F238E27FC236}">
-                <a16:creationId xmlns:a16="http://schemas.microsoft.com/office/drawing/2014/main" id="{B75B3312-72DC-41E3-B907-BA9BF8C12C04}"/>
+                <a16:creationId xmlns:a16="http://schemas.microsoft.com/office/drawing/2014/main" id="{286D6D77-2E91-4B6A-BB97-376C32F71A0C}"/>
               </a:ext>
             </a:extLst>
           </p:cNvPr>
@@ -12092,7 +12092,7 @@
           <p:cNvPr id="13" name="">
             <a:extLst xmlns:a="http://schemas.openxmlformats.org/drawingml/2006/main">
               <a:ext uri="{FF2B5EF4-FFF2-40B4-BE49-F238E27FC236}">
-                <a16:creationId xmlns:a16="http://schemas.microsoft.com/office/drawing/2014/main" id="{22C8CB97-D0A4-4BDC-97C9-9E3D75D0EBBD}"/>
+                <a16:creationId xmlns:a16="http://schemas.microsoft.com/office/drawing/2014/main" id="{9094DE5A-28D9-4556-A145-AC3425E1FE64}"/>
               </a:ext>
             </a:extLst>
           </p:cNvPr>
@@ -12142,7 +12142,7 @@
           <p:cNvPr id="14" name="">
             <a:extLst xmlns:a="http://schemas.openxmlformats.org/drawingml/2006/main">
               <a:ext uri="{FF2B5EF4-FFF2-40B4-BE49-F238E27FC236}">
-                <a16:creationId xmlns:a16="http://schemas.microsoft.com/office/drawing/2014/main" id="{63ECE87A-7151-4A7E-A138-0287427785C9}"/>
+                <a16:creationId xmlns:a16="http://schemas.microsoft.com/office/drawing/2014/main" id="{05763E88-10C7-43B7-80B7-F9E8BF9CA4A2}"/>
               </a:ext>
             </a:extLst>
           </p:cNvPr>
@@ -12173,7 +12173,7 @@
           <p:cNvPr id="15" name="">
             <a:extLst xmlns:a="http://schemas.openxmlformats.org/drawingml/2006/main">
               <a:ext uri="{FF2B5EF4-FFF2-40B4-BE49-F238E27FC236}">
-                <a16:creationId xmlns:a16="http://schemas.microsoft.com/office/drawing/2014/main" id="{1BE19E3F-3BEA-4B87-8DAF-17FB86276120}"/>
+                <a16:creationId xmlns:a16="http://schemas.microsoft.com/office/drawing/2014/main" id="{F17F28D2-14A8-4F10-A380-C500BA14113C}"/>
               </a:ext>
             </a:extLst>
           </p:cNvPr>
@@ -12223,7 +12223,7 @@
           <p:cNvPr id="16" name="">
             <a:extLst xmlns:a="http://schemas.openxmlformats.org/drawingml/2006/main">
               <a:ext uri="{FF2B5EF4-FFF2-40B4-BE49-F238E27FC236}">
-                <a16:creationId xmlns:a16="http://schemas.microsoft.com/office/drawing/2014/main" id="{CC451C70-E4E6-48E5-B05E-FCCF8C9C7CFE}"/>
+                <a16:creationId xmlns:a16="http://schemas.microsoft.com/office/drawing/2014/main" id="{4AA2ACAE-4D72-4569-ACCA-CC3F82D78837}"/>
               </a:ext>
             </a:extLst>
           </p:cNvPr>
@@ -12254,7 +12254,7 @@
           <p:cNvPr id="17" name="">
             <a:extLst xmlns:a="http://schemas.openxmlformats.org/drawingml/2006/main">
               <a:ext uri="{FF2B5EF4-FFF2-40B4-BE49-F238E27FC236}">
-                <a16:creationId xmlns:a16="http://schemas.microsoft.com/office/drawing/2014/main" id="{ABAC40A2-F9B9-4E26-A658-A1B6D5A7321A}"/>
+                <a16:creationId xmlns:a16="http://schemas.microsoft.com/office/drawing/2014/main" id="{223143D4-513C-44E8-950B-B695DBE049C5}"/>
               </a:ext>
             </a:extLst>
           </p:cNvPr>
@@ -12304,7 +12304,7 @@
           <p:cNvPr id="18" name="">
             <a:extLst xmlns:a="http://schemas.openxmlformats.org/drawingml/2006/main">
               <a:ext uri="{FF2B5EF4-FFF2-40B4-BE49-F238E27FC236}">
-                <a16:creationId xmlns:a16="http://schemas.microsoft.com/office/drawing/2014/main" id="{80388698-27CA-4015-B4EF-9259A313B18B}"/>
+                <a16:creationId xmlns:a16="http://schemas.microsoft.com/office/drawing/2014/main" id="{395BF63C-389B-47A2-A2AF-D5D20A7183D0}"/>
               </a:ext>
             </a:extLst>
           </p:cNvPr>
@@ -12335,7 +12335,7 @@
           <p:cNvPr id="19" name="">
             <a:extLst xmlns:a="http://schemas.openxmlformats.org/drawingml/2006/main">
               <a:ext uri="{FF2B5EF4-FFF2-40B4-BE49-F238E27FC236}">
-                <a16:creationId xmlns:a16="http://schemas.microsoft.com/office/drawing/2014/main" id="{3F5226FC-A8D1-4AEF-BCAA-43FF3BFD6C8A}"/>
+                <a16:creationId xmlns:a16="http://schemas.microsoft.com/office/drawing/2014/main" id="{0164A965-E751-4345-BED3-5DF7BE14A19B}"/>
               </a:ext>
             </a:extLst>
           </p:cNvPr>
@@ -12385,7 +12385,7 @@
           <p:cNvPr id="20" name="">
             <a:extLst xmlns:a="http://schemas.openxmlformats.org/drawingml/2006/main">
               <a:ext uri="{FF2B5EF4-FFF2-40B4-BE49-F238E27FC236}">
-                <a16:creationId xmlns:a16="http://schemas.microsoft.com/office/drawing/2014/main" id="{41FF2A2B-7F08-42F3-AC17-3AC266B6684F}"/>
+                <a16:creationId xmlns:a16="http://schemas.microsoft.com/office/drawing/2014/main" id="{4D492C52-E199-4E1C-A9D5-7F42F9BA2F2A}"/>
               </a:ext>
             </a:extLst>
           </p:cNvPr>
@@ -12416,7 +12416,7 @@
           <p:cNvPr id="21" name="">
             <a:extLst xmlns:a="http://schemas.openxmlformats.org/drawingml/2006/main">
               <a:ext uri="{FF2B5EF4-FFF2-40B4-BE49-F238E27FC236}">
-                <a16:creationId xmlns:a16="http://schemas.microsoft.com/office/drawing/2014/main" id="{702ACE36-FA9B-4CE3-ABDA-0E1DE5AA8C97}"/>
+                <a16:creationId xmlns:a16="http://schemas.microsoft.com/office/drawing/2014/main" id="{83227276-CFC1-4436-9276-24BDC42526D1}"/>
               </a:ext>
             </a:extLst>
           </p:cNvPr>
@@ -12466,7 +12466,7 @@
           <p:cNvPr id="22" name="">
             <a:extLst xmlns:a="http://schemas.openxmlformats.org/drawingml/2006/main">
               <a:ext uri="{FF2B5EF4-FFF2-40B4-BE49-F238E27FC236}">
-                <a16:creationId xmlns:a16="http://schemas.microsoft.com/office/drawing/2014/main" id="{1BEE4436-C5BC-4F55-89D8-DAAB3630FD06}"/>
+                <a16:creationId xmlns:a16="http://schemas.microsoft.com/office/drawing/2014/main" id="{F2340356-05D6-4CB7-800E-E54758A95808}"/>
               </a:ext>
             </a:extLst>
           </p:cNvPr>
@@ -12497,7 +12497,7 @@
           <p:cNvPr id="23" name="">
             <a:extLst xmlns:a="http://schemas.openxmlformats.org/drawingml/2006/main">
               <a:ext uri="{FF2B5EF4-FFF2-40B4-BE49-F238E27FC236}">
-                <a16:creationId xmlns:a16="http://schemas.microsoft.com/office/drawing/2014/main" id="{16AC4F9E-F8C0-4AA6-B6A2-A577E6E0D89D}"/>
+                <a16:creationId xmlns:a16="http://schemas.microsoft.com/office/drawing/2014/main" id="{ECB74FDF-5ED2-43BD-AE8A-6C08E55B4562}"/>
               </a:ext>
             </a:extLst>
           </p:cNvPr>
@@ -12547,7 +12547,7 @@
           <p:cNvPr id="24" name="">
             <a:extLst xmlns:a="http://schemas.openxmlformats.org/drawingml/2006/main">
               <a:ext uri="{FF2B5EF4-FFF2-40B4-BE49-F238E27FC236}">
-                <a16:creationId xmlns:a16="http://schemas.microsoft.com/office/drawing/2014/main" id="{1F170BB7-9DEB-4EDB-AD27-64381399F32E}"/>
+                <a16:creationId xmlns:a16="http://schemas.microsoft.com/office/drawing/2014/main" id="{B43F52AD-FD77-4EBF-8C1D-E1F06AC0389C}"/>
               </a:ext>
             </a:extLst>
           </p:cNvPr>
@@ -12587,7 +12587,7 @@
                   <a:srgbClr val="000000"/>
                 </a:solidFill>
               </a:rPr>
-              <a:t>Interview line: I did not run Meridian because the data does not support a production MMM yet. I designed exactly where it would plug in once real spend and outcomes exist.</a:t>
+              <a:t>Project caveat: I did not run Meridian because the data does not support a production MMM yet. I designed exactly where it would plug in once real spend and outcomes exist.</a:t>
             </a:r>
           </a:p>
         </p:txBody>
@@ -12595,7 +12595,7 @@
     </p:spTree>
     <p:extLst>
       <p:ext uri="{BB962C8B-B14F-4D97-AF65-F5344CB8AC3E}">
-        <p14:creationId xmlns:p14="http://schemas.microsoft.com/office/powerpoint/2010/main" val="853547723"/>
+        <p14:creationId xmlns:p14="http://schemas.microsoft.com/office/powerpoint/2010/main" val="1873779145"/>
       </p:ext>
     </p:extLst>
   </p:cSld>

</xml_diff>